<commit_message>
more work on salo data
</commit_message>
<xml_diff>
--- a/figures_for_paper/selections_figure.pptx
+++ b/figures_for_paper/selections_figure.pptx
@@ -4,9 +4,13 @@
   <p:sldMasterIdLst>
     <p:sldMasterId id="2147483648" r:id="rId1"/>
   </p:sldMasterIdLst>
+  <p:notesMasterIdLst>
+    <p:notesMasterId r:id="rId5"/>
+  </p:notesMasterIdLst>
   <p:sldIdLst>
     <p:sldId id="256" r:id="rId2"/>
     <p:sldId id="257" r:id="rId3"/>
+    <p:sldId id="258" r:id="rId4"/>
   </p:sldIdLst>
   <p:sldSz cx="12192000" cy="6858000"/>
   <p:notesSz cx="6858000" cy="9144000"/>
@@ -121,6 +125,440 @@
 </p1510:revInfo>
 </file>
 
+<file path=ppt/notesMasters/notesMaster1.xml><?xml version="1.0" encoding="utf-8"?>
+<p:notesMaster xmlns:a="http://schemas.openxmlformats.org/drawingml/2006/main" xmlns:r="http://schemas.openxmlformats.org/officeDocument/2006/relationships" xmlns:p="http://schemas.openxmlformats.org/presentationml/2006/main">
+  <p:cSld>
+    <p:bg>
+      <p:bgRef idx="1001">
+        <a:schemeClr val="bg1"/>
+      </p:bgRef>
+    </p:bg>
+    <p:spTree>
+      <p:nvGrpSpPr>
+        <p:cNvPr id="1" name=""/>
+        <p:cNvGrpSpPr/>
+        <p:nvPr/>
+      </p:nvGrpSpPr>
+      <p:grpSpPr>
+        <a:xfrm>
+          <a:off x="0" y="0"/>
+          <a:ext cx="0" cy="0"/>
+          <a:chOff x="0" y="0"/>
+          <a:chExt cx="0" cy="0"/>
+        </a:xfrm>
+      </p:grpSpPr>
+      <p:sp>
+        <p:nvSpPr>
+          <p:cNvPr id="2" name="Header Placeholder 1"/>
+          <p:cNvSpPr>
+            <a:spLocks noGrp="1"/>
+          </p:cNvSpPr>
+          <p:nvPr>
+            <p:ph type="hdr" sz="quarter"/>
+          </p:nvPr>
+        </p:nvSpPr>
+        <p:spPr>
+          <a:xfrm>
+            <a:off x="0" y="0"/>
+            <a:ext cx="2971800" cy="458788"/>
+          </a:xfrm>
+          <a:prstGeom prst="rect">
+            <a:avLst/>
+          </a:prstGeom>
+        </p:spPr>
+        <p:txBody>
+          <a:bodyPr vert="horz" lIns="91440" tIns="45720" rIns="91440" bIns="45720" rtlCol="0"/>
+          <a:lstStyle>
+            <a:lvl1pPr algn="l">
+              <a:defRPr sz="1200"/>
+            </a:lvl1pPr>
+          </a:lstStyle>
+          <a:p>
+            <a:endParaRPr lang="en-GB"/>
+          </a:p>
+        </p:txBody>
+      </p:sp>
+      <p:sp>
+        <p:nvSpPr>
+          <p:cNvPr id="3" name="Date Placeholder 2"/>
+          <p:cNvSpPr>
+            <a:spLocks noGrp="1"/>
+          </p:cNvSpPr>
+          <p:nvPr>
+            <p:ph type="dt" idx="1"/>
+          </p:nvPr>
+        </p:nvSpPr>
+        <p:spPr>
+          <a:xfrm>
+            <a:off x="3884613" y="0"/>
+            <a:ext cx="2971800" cy="458788"/>
+          </a:xfrm>
+          <a:prstGeom prst="rect">
+            <a:avLst/>
+          </a:prstGeom>
+        </p:spPr>
+        <p:txBody>
+          <a:bodyPr vert="horz" lIns="91440" tIns="45720" rIns="91440" bIns="45720" rtlCol="0"/>
+          <a:lstStyle>
+            <a:lvl1pPr algn="r">
+              <a:defRPr sz="1200"/>
+            </a:lvl1pPr>
+          </a:lstStyle>
+          <a:p>
+            <a:fld id="{48CACFA4-D937-4459-849E-E86956FD20F6}" type="datetimeFigureOut">
+              <a:rPr lang="en-GB" smtClean="0"/>
+              <a:t>16/02/2026</a:t>
+            </a:fld>
+            <a:endParaRPr lang="en-GB"/>
+          </a:p>
+        </p:txBody>
+      </p:sp>
+      <p:sp>
+        <p:nvSpPr>
+          <p:cNvPr id="4" name="Slide Image Placeholder 3"/>
+          <p:cNvSpPr>
+            <a:spLocks noGrp="1" noRot="1" noChangeAspect="1"/>
+          </p:cNvSpPr>
+          <p:nvPr>
+            <p:ph type="sldImg" idx="2"/>
+          </p:nvPr>
+        </p:nvSpPr>
+        <p:spPr>
+          <a:xfrm>
+            <a:off x="685800" y="1143000"/>
+            <a:ext cx="5486400" cy="3086100"/>
+          </a:xfrm>
+          <a:prstGeom prst="rect">
+            <a:avLst/>
+          </a:prstGeom>
+          <a:noFill/>
+          <a:ln w="12700">
+            <a:solidFill>
+              <a:prstClr val="black"/>
+            </a:solidFill>
+          </a:ln>
+        </p:spPr>
+        <p:txBody>
+          <a:bodyPr vert="horz" lIns="91440" tIns="45720" rIns="91440" bIns="45720" rtlCol="0" anchor="ctr"/>
+          <a:lstStyle/>
+          <a:p>
+            <a:endParaRPr lang="en-GB"/>
+          </a:p>
+        </p:txBody>
+      </p:sp>
+      <p:sp>
+        <p:nvSpPr>
+          <p:cNvPr id="5" name="Notes Placeholder 4"/>
+          <p:cNvSpPr>
+            <a:spLocks noGrp="1"/>
+          </p:cNvSpPr>
+          <p:nvPr>
+            <p:ph type="body" sz="quarter" idx="3"/>
+          </p:nvPr>
+        </p:nvSpPr>
+        <p:spPr>
+          <a:xfrm>
+            <a:off x="685800" y="4400550"/>
+            <a:ext cx="5486400" cy="3600450"/>
+          </a:xfrm>
+          <a:prstGeom prst="rect">
+            <a:avLst/>
+          </a:prstGeom>
+        </p:spPr>
+        <p:txBody>
+          <a:bodyPr vert="horz" lIns="91440" tIns="45720" rIns="91440" bIns="45720" rtlCol="0"/>
+          <a:lstStyle/>
+          <a:p>
+            <a:pPr lvl="0"/>
+            <a:r>
+              <a:rPr lang="en-US"/>
+              <a:t>Click to edit Master text styles</a:t>
+            </a:r>
+          </a:p>
+          <a:p>
+            <a:pPr lvl="1"/>
+            <a:r>
+              <a:rPr lang="en-US"/>
+              <a:t>Second level</a:t>
+            </a:r>
+          </a:p>
+          <a:p>
+            <a:pPr lvl="2"/>
+            <a:r>
+              <a:rPr lang="en-US"/>
+              <a:t>Third level</a:t>
+            </a:r>
+          </a:p>
+          <a:p>
+            <a:pPr lvl="3"/>
+            <a:r>
+              <a:rPr lang="en-US"/>
+              <a:t>Fourth level</a:t>
+            </a:r>
+          </a:p>
+          <a:p>
+            <a:pPr lvl="4"/>
+            <a:r>
+              <a:rPr lang="en-US"/>
+              <a:t>Fifth level</a:t>
+            </a:r>
+            <a:endParaRPr lang="en-GB"/>
+          </a:p>
+        </p:txBody>
+      </p:sp>
+      <p:sp>
+        <p:nvSpPr>
+          <p:cNvPr id="6" name="Footer Placeholder 5"/>
+          <p:cNvSpPr>
+            <a:spLocks noGrp="1"/>
+          </p:cNvSpPr>
+          <p:nvPr>
+            <p:ph type="ftr" sz="quarter" idx="4"/>
+          </p:nvPr>
+        </p:nvSpPr>
+        <p:spPr>
+          <a:xfrm>
+            <a:off x="0" y="8685213"/>
+            <a:ext cx="2971800" cy="458787"/>
+          </a:xfrm>
+          <a:prstGeom prst="rect">
+            <a:avLst/>
+          </a:prstGeom>
+        </p:spPr>
+        <p:txBody>
+          <a:bodyPr vert="horz" lIns="91440" tIns="45720" rIns="91440" bIns="45720" rtlCol="0" anchor="b"/>
+          <a:lstStyle>
+            <a:lvl1pPr algn="l">
+              <a:defRPr sz="1200"/>
+            </a:lvl1pPr>
+          </a:lstStyle>
+          <a:p>
+            <a:endParaRPr lang="en-GB"/>
+          </a:p>
+        </p:txBody>
+      </p:sp>
+      <p:sp>
+        <p:nvSpPr>
+          <p:cNvPr id="7" name="Slide Number Placeholder 6"/>
+          <p:cNvSpPr>
+            <a:spLocks noGrp="1"/>
+          </p:cNvSpPr>
+          <p:nvPr>
+            <p:ph type="sldNum" sz="quarter" idx="5"/>
+          </p:nvPr>
+        </p:nvSpPr>
+        <p:spPr>
+          <a:xfrm>
+            <a:off x="3884613" y="8685213"/>
+            <a:ext cx="2971800" cy="458787"/>
+          </a:xfrm>
+          <a:prstGeom prst="rect">
+            <a:avLst/>
+          </a:prstGeom>
+        </p:spPr>
+        <p:txBody>
+          <a:bodyPr vert="horz" lIns="91440" tIns="45720" rIns="91440" bIns="45720" rtlCol="0" anchor="b"/>
+          <a:lstStyle>
+            <a:lvl1pPr algn="r">
+              <a:defRPr sz="1200"/>
+            </a:lvl1pPr>
+          </a:lstStyle>
+          <a:p>
+            <a:fld id="{A9629104-480C-440F-BCBB-A5EECFE23F4D}" type="slidenum">
+              <a:rPr lang="en-GB" smtClean="0"/>
+              <a:t>‹#›</a:t>
+            </a:fld>
+            <a:endParaRPr lang="en-GB"/>
+          </a:p>
+        </p:txBody>
+      </p:sp>
+    </p:spTree>
+    <p:extLst>
+      <p:ext uri="{BB962C8B-B14F-4D97-AF65-F5344CB8AC3E}">
+        <p14:creationId xmlns:p14="http://schemas.microsoft.com/office/powerpoint/2010/main" val="4012588351"/>
+      </p:ext>
+    </p:extLst>
+  </p:cSld>
+  <p:clrMap bg1="lt1" tx1="dk1" bg2="lt2" tx2="dk2" accent1="accent1" accent2="accent2" accent3="accent3" accent4="accent4" accent5="accent5" accent6="accent6" hlink="hlink" folHlink="folHlink"/>
+  <p:notesStyle>
+    <a:lvl1pPr marL="0" algn="l" defTabSz="914400" rtl="0" eaLnBrk="1" latinLnBrk="0" hangingPunct="1">
+      <a:defRPr sz="1200" kern="1200">
+        <a:solidFill>
+          <a:schemeClr val="tx1"/>
+        </a:solidFill>
+        <a:latin typeface="+mn-lt"/>
+        <a:ea typeface="+mn-ea"/>
+        <a:cs typeface="+mn-cs"/>
+      </a:defRPr>
+    </a:lvl1pPr>
+    <a:lvl2pPr marL="457200" algn="l" defTabSz="914400" rtl="0" eaLnBrk="1" latinLnBrk="0" hangingPunct="1">
+      <a:defRPr sz="1200" kern="1200">
+        <a:solidFill>
+          <a:schemeClr val="tx1"/>
+        </a:solidFill>
+        <a:latin typeface="+mn-lt"/>
+        <a:ea typeface="+mn-ea"/>
+        <a:cs typeface="+mn-cs"/>
+      </a:defRPr>
+    </a:lvl2pPr>
+    <a:lvl3pPr marL="914400" algn="l" defTabSz="914400" rtl="0" eaLnBrk="1" latinLnBrk="0" hangingPunct="1">
+      <a:defRPr sz="1200" kern="1200">
+        <a:solidFill>
+          <a:schemeClr val="tx1"/>
+        </a:solidFill>
+        <a:latin typeface="+mn-lt"/>
+        <a:ea typeface="+mn-ea"/>
+        <a:cs typeface="+mn-cs"/>
+      </a:defRPr>
+    </a:lvl3pPr>
+    <a:lvl4pPr marL="1371600" algn="l" defTabSz="914400" rtl="0" eaLnBrk="1" latinLnBrk="0" hangingPunct="1">
+      <a:defRPr sz="1200" kern="1200">
+        <a:solidFill>
+          <a:schemeClr val="tx1"/>
+        </a:solidFill>
+        <a:latin typeface="+mn-lt"/>
+        <a:ea typeface="+mn-ea"/>
+        <a:cs typeface="+mn-cs"/>
+      </a:defRPr>
+    </a:lvl4pPr>
+    <a:lvl5pPr marL="1828800" algn="l" defTabSz="914400" rtl="0" eaLnBrk="1" latinLnBrk="0" hangingPunct="1">
+      <a:defRPr sz="1200" kern="1200">
+        <a:solidFill>
+          <a:schemeClr val="tx1"/>
+        </a:solidFill>
+        <a:latin typeface="+mn-lt"/>
+        <a:ea typeface="+mn-ea"/>
+        <a:cs typeface="+mn-cs"/>
+      </a:defRPr>
+    </a:lvl5pPr>
+    <a:lvl6pPr marL="2286000" algn="l" defTabSz="914400" rtl="0" eaLnBrk="1" latinLnBrk="0" hangingPunct="1">
+      <a:defRPr sz="1200" kern="1200">
+        <a:solidFill>
+          <a:schemeClr val="tx1"/>
+        </a:solidFill>
+        <a:latin typeface="+mn-lt"/>
+        <a:ea typeface="+mn-ea"/>
+        <a:cs typeface="+mn-cs"/>
+      </a:defRPr>
+    </a:lvl6pPr>
+    <a:lvl7pPr marL="2743200" algn="l" defTabSz="914400" rtl="0" eaLnBrk="1" latinLnBrk="0" hangingPunct="1">
+      <a:defRPr sz="1200" kern="1200">
+        <a:solidFill>
+          <a:schemeClr val="tx1"/>
+        </a:solidFill>
+        <a:latin typeface="+mn-lt"/>
+        <a:ea typeface="+mn-ea"/>
+        <a:cs typeface="+mn-cs"/>
+      </a:defRPr>
+    </a:lvl7pPr>
+    <a:lvl8pPr marL="3200400" algn="l" defTabSz="914400" rtl="0" eaLnBrk="1" latinLnBrk="0" hangingPunct="1">
+      <a:defRPr sz="1200" kern="1200">
+        <a:solidFill>
+          <a:schemeClr val="tx1"/>
+        </a:solidFill>
+        <a:latin typeface="+mn-lt"/>
+        <a:ea typeface="+mn-ea"/>
+        <a:cs typeface="+mn-cs"/>
+      </a:defRPr>
+    </a:lvl8pPr>
+    <a:lvl9pPr marL="3657600" algn="l" defTabSz="914400" rtl="0" eaLnBrk="1" latinLnBrk="0" hangingPunct="1">
+      <a:defRPr sz="1200" kern="1200">
+        <a:solidFill>
+          <a:schemeClr val="tx1"/>
+        </a:solidFill>
+        <a:latin typeface="+mn-lt"/>
+        <a:ea typeface="+mn-ea"/>
+        <a:cs typeface="+mn-cs"/>
+      </a:defRPr>
+    </a:lvl9pPr>
+  </p:notesStyle>
+</p:notesMaster>
+</file>
+
+<file path=ppt/notesSlides/notesSlide1.xml><?xml version="1.0" encoding="utf-8"?>
+<p:notes xmlns:a="http://schemas.openxmlformats.org/drawingml/2006/main" xmlns:r="http://schemas.openxmlformats.org/officeDocument/2006/relationships" xmlns:p="http://schemas.openxmlformats.org/presentationml/2006/main">
+  <p:cSld>
+    <p:spTree>
+      <p:nvGrpSpPr>
+        <p:cNvPr id="1" name=""/>
+        <p:cNvGrpSpPr/>
+        <p:nvPr/>
+      </p:nvGrpSpPr>
+      <p:grpSpPr>
+        <a:xfrm>
+          <a:off x="0" y="0"/>
+          <a:ext cx="0" cy="0"/>
+          <a:chOff x="0" y="0"/>
+          <a:chExt cx="0" cy="0"/>
+        </a:xfrm>
+      </p:grpSpPr>
+      <p:sp>
+        <p:nvSpPr>
+          <p:cNvPr id="2" name="Slide Image Placeholder 1"/>
+          <p:cNvSpPr>
+            <a:spLocks noGrp="1" noRot="1" noChangeAspect="1"/>
+          </p:cNvSpPr>
+          <p:nvPr>
+            <p:ph type="sldImg"/>
+          </p:nvPr>
+        </p:nvSpPr>
+        <p:spPr/>
+      </p:sp>
+      <p:sp>
+        <p:nvSpPr>
+          <p:cNvPr id="3" name="Notes Placeholder 2"/>
+          <p:cNvSpPr>
+            <a:spLocks noGrp="1"/>
+          </p:cNvSpPr>
+          <p:nvPr>
+            <p:ph type="body" idx="1"/>
+          </p:nvPr>
+        </p:nvSpPr>
+        <p:spPr/>
+        <p:txBody>
+          <a:bodyPr/>
+          <a:lstStyle/>
+          <a:p>
+            <a:endParaRPr lang="en-GB" dirty="0"/>
+          </a:p>
+        </p:txBody>
+      </p:sp>
+      <p:sp>
+        <p:nvSpPr>
+          <p:cNvPr id="4" name="Slide Number Placeholder 3"/>
+          <p:cNvSpPr>
+            <a:spLocks noGrp="1"/>
+          </p:cNvSpPr>
+          <p:nvPr>
+            <p:ph type="sldNum" sz="quarter" idx="5"/>
+          </p:nvPr>
+        </p:nvSpPr>
+        <p:spPr/>
+        <p:txBody>
+          <a:bodyPr/>
+          <a:lstStyle/>
+          <a:p>
+            <a:fld id="{A9629104-480C-440F-BCBB-A5EECFE23F4D}" type="slidenum">
+              <a:rPr lang="en-GB" smtClean="0"/>
+              <a:t>3</a:t>
+            </a:fld>
+            <a:endParaRPr lang="en-GB"/>
+          </a:p>
+        </p:txBody>
+      </p:sp>
+    </p:spTree>
+    <p:extLst>
+      <p:ext uri="{BB962C8B-B14F-4D97-AF65-F5344CB8AC3E}">
+        <p14:creationId xmlns:p14="http://schemas.microsoft.com/office/powerpoint/2010/main" val="1644384681"/>
+      </p:ext>
+    </p:extLst>
+  </p:cSld>
+  <p:clrMapOvr>
+    <a:masterClrMapping/>
+  </p:clrMapOvr>
+</p:notes>
+</file>
+
 <file path=ppt/slideLayouts/slideLayout1.xml><?xml version="1.0" encoding="utf-8"?>
 <p:sldLayout xmlns:a="http://schemas.openxmlformats.org/drawingml/2006/main" xmlns:r="http://schemas.openxmlformats.org/officeDocument/2006/relationships" xmlns:p="http://schemas.openxmlformats.org/presentationml/2006/main" type="title" preserve="1">
   <p:cSld name="Title Slide">
@@ -270,7 +708,7 @@
           <a:p>
             <a:fld id="{0D03F4F1-D4F0-234F-AE12-F18A5B7D4C76}" type="datetimeFigureOut">
               <a:rPr lang="en-US" smtClean="0"/>
-              <a:t>6/11/2025</a:t>
+              <a:t>2/16/2026</a:t>
             </a:fld>
             <a:endParaRPr lang="en-US"/>
           </a:p>
@@ -470,7 +908,7 @@
           <a:p>
             <a:fld id="{0D03F4F1-D4F0-234F-AE12-F18A5B7D4C76}" type="datetimeFigureOut">
               <a:rPr lang="en-US" smtClean="0"/>
-              <a:t>6/11/2025</a:t>
+              <a:t>2/16/2026</a:t>
             </a:fld>
             <a:endParaRPr lang="en-US"/>
           </a:p>
@@ -680,7 +1118,7 @@
           <a:p>
             <a:fld id="{0D03F4F1-D4F0-234F-AE12-F18A5B7D4C76}" type="datetimeFigureOut">
               <a:rPr lang="en-US" smtClean="0"/>
-              <a:t>6/11/2025</a:t>
+              <a:t>2/16/2026</a:t>
             </a:fld>
             <a:endParaRPr lang="en-US"/>
           </a:p>
@@ -880,7 +1318,7 @@
           <a:p>
             <a:fld id="{0D03F4F1-D4F0-234F-AE12-F18A5B7D4C76}" type="datetimeFigureOut">
               <a:rPr lang="en-US" smtClean="0"/>
-              <a:t>6/11/2025</a:t>
+              <a:t>2/16/2026</a:t>
             </a:fld>
             <a:endParaRPr lang="en-US"/>
           </a:p>
@@ -1156,7 +1594,7 @@
           <a:p>
             <a:fld id="{0D03F4F1-D4F0-234F-AE12-F18A5B7D4C76}" type="datetimeFigureOut">
               <a:rPr lang="en-US" smtClean="0"/>
-              <a:t>6/11/2025</a:t>
+              <a:t>2/16/2026</a:t>
             </a:fld>
             <a:endParaRPr lang="en-US"/>
           </a:p>
@@ -1424,7 +1862,7 @@
           <a:p>
             <a:fld id="{0D03F4F1-D4F0-234F-AE12-F18A5B7D4C76}" type="datetimeFigureOut">
               <a:rPr lang="en-US" smtClean="0"/>
-              <a:t>6/11/2025</a:t>
+              <a:t>2/16/2026</a:t>
             </a:fld>
             <a:endParaRPr lang="en-US"/>
           </a:p>
@@ -1839,7 +2277,7 @@
           <a:p>
             <a:fld id="{0D03F4F1-D4F0-234F-AE12-F18A5B7D4C76}" type="datetimeFigureOut">
               <a:rPr lang="en-US" smtClean="0"/>
-              <a:t>6/11/2025</a:t>
+              <a:t>2/16/2026</a:t>
             </a:fld>
             <a:endParaRPr lang="en-US"/>
           </a:p>
@@ -1981,7 +2419,7 @@
           <a:p>
             <a:fld id="{0D03F4F1-D4F0-234F-AE12-F18A5B7D4C76}" type="datetimeFigureOut">
               <a:rPr lang="en-US" smtClean="0"/>
-              <a:t>6/11/2025</a:t>
+              <a:t>2/16/2026</a:t>
             </a:fld>
             <a:endParaRPr lang="en-US"/>
           </a:p>
@@ -2094,7 +2532,7 @@
           <a:p>
             <a:fld id="{0D03F4F1-D4F0-234F-AE12-F18A5B7D4C76}" type="datetimeFigureOut">
               <a:rPr lang="en-US" smtClean="0"/>
-              <a:t>6/11/2025</a:t>
+              <a:t>2/16/2026</a:t>
             </a:fld>
             <a:endParaRPr lang="en-US"/>
           </a:p>
@@ -2407,7 +2845,7 @@
           <a:p>
             <a:fld id="{0D03F4F1-D4F0-234F-AE12-F18A5B7D4C76}" type="datetimeFigureOut">
               <a:rPr lang="en-US" smtClean="0"/>
-              <a:t>6/11/2025</a:t>
+              <a:t>2/16/2026</a:t>
             </a:fld>
             <a:endParaRPr lang="en-US"/>
           </a:p>
@@ -2696,7 +3134,7 @@
           <a:p>
             <a:fld id="{0D03F4F1-D4F0-234F-AE12-F18A5B7D4C76}" type="datetimeFigureOut">
               <a:rPr lang="en-US" smtClean="0"/>
-              <a:t>6/11/2025</a:t>
+              <a:t>2/16/2026</a:t>
             </a:fld>
             <a:endParaRPr lang="en-US"/>
           </a:p>
@@ -2939,7 +3377,7 @@
           <a:p>
             <a:fld id="{0D03F4F1-D4F0-234F-AE12-F18A5B7D4C76}" type="datetimeFigureOut">
               <a:rPr lang="en-US" smtClean="0"/>
-              <a:t>6/11/2025</a:t>
+              <a:t>2/16/2026</a:t>
             </a:fld>
             <a:endParaRPr lang="en-US"/>
           </a:p>
@@ -5522,6 +5960,2168 @@
 </p:sld>
 </file>
 
+<file path=ppt/slides/slide3.xml><?xml version="1.0" encoding="utf-8"?>
+<p:sld xmlns:a="http://schemas.openxmlformats.org/drawingml/2006/main" xmlns:r="http://schemas.openxmlformats.org/officeDocument/2006/relationships" xmlns:p="http://schemas.openxmlformats.org/presentationml/2006/main">
+  <p:cSld>
+    <p:spTree>
+      <p:nvGrpSpPr>
+        <p:cNvPr id="1" name=""/>
+        <p:cNvGrpSpPr/>
+        <p:nvPr/>
+      </p:nvGrpSpPr>
+      <p:grpSpPr>
+        <a:xfrm>
+          <a:off x="0" y="0"/>
+          <a:ext cx="0" cy="0"/>
+          <a:chOff x="0" y="0"/>
+          <a:chExt cx="0" cy="0"/>
+        </a:xfrm>
+      </p:grpSpPr>
+      <p:pic>
+        <p:nvPicPr>
+          <p:cNvPr id="66" name="Picture 65" descr="A group of squares on a gray background&#10;&#10;Description automatically generated">
+            <a:extLst>
+              <a:ext uri="{FF2B5EF4-FFF2-40B4-BE49-F238E27FC236}">
+                <a16:creationId xmlns:a16="http://schemas.microsoft.com/office/drawing/2014/main" id="{48D78EEC-FE13-1422-50F7-657A1625EC9F}"/>
+              </a:ext>
+            </a:extLst>
+          </p:cNvPr>
+          <p:cNvPicPr>
+            <a:picLocks noChangeAspect="1"/>
+          </p:cNvPicPr>
+          <p:nvPr/>
+        </p:nvPicPr>
+        <p:blipFill>
+          <a:blip r:embed="rId3"/>
+          <a:stretch>
+            <a:fillRect/>
+          </a:stretch>
+        </p:blipFill>
+        <p:spPr>
+          <a:xfrm>
+            <a:off x="6000736" y="2214136"/>
+            <a:ext cx="2525504" cy="2565276"/>
+          </a:xfrm>
+          <a:prstGeom prst="rect">
+            <a:avLst/>
+          </a:prstGeom>
+        </p:spPr>
+      </p:pic>
+      <p:pic>
+        <p:nvPicPr>
+          <p:cNvPr id="63" name="Picture 62" descr="A group of squares on a gray background&#10;&#10;Description automatically generated">
+            <a:extLst>
+              <a:ext uri="{FF2B5EF4-FFF2-40B4-BE49-F238E27FC236}">
+                <a16:creationId xmlns:a16="http://schemas.microsoft.com/office/drawing/2014/main" id="{86F4A635-DBED-E0DA-2534-81E01CE93C34}"/>
+              </a:ext>
+            </a:extLst>
+          </p:cNvPr>
+          <p:cNvPicPr>
+            <a:picLocks noChangeAspect="1"/>
+          </p:cNvPicPr>
+          <p:nvPr/>
+        </p:nvPicPr>
+        <p:blipFill>
+          <a:blip r:embed="rId3"/>
+          <a:stretch>
+            <a:fillRect/>
+          </a:stretch>
+        </p:blipFill>
+        <p:spPr>
+          <a:xfrm>
+            <a:off x="3133741" y="3860400"/>
+            <a:ext cx="2525504" cy="2565276"/>
+          </a:xfrm>
+          <a:prstGeom prst="rect">
+            <a:avLst/>
+          </a:prstGeom>
+        </p:spPr>
+      </p:pic>
+      <p:pic>
+        <p:nvPicPr>
+          <p:cNvPr id="62" name="Picture 61" descr="A group of squares on a gray background&#10;&#10;Description automatically generated">
+            <a:extLst>
+              <a:ext uri="{FF2B5EF4-FFF2-40B4-BE49-F238E27FC236}">
+                <a16:creationId xmlns:a16="http://schemas.microsoft.com/office/drawing/2014/main" id="{3FD62678-23B0-DCEE-0075-D608241ABDF2}"/>
+              </a:ext>
+            </a:extLst>
+          </p:cNvPr>
+          <p:cNvPicPr>
+            <a:picLocks noChangeAspect="1"/>
+          </p:cNvPicPr>
+          <p:nvPr/>
+        </p:nvPicPr>
+        <p:blipFill>
+          <a:blip r:embed="rId3"/>
+          <a:stretch>
+            <a:fillRect/>
+          </a:stretch>
+        </p:blipFill>
+        <p:spPr>
+          <a:xfrm>
+            <a:off x="209959" y="3866351"/>
+            <a:ext cx="2525504" cy="2565276"/>
+          </a:xfrm>
+          <a:prstGeom prst="rect">
+            <a:avLst/>
+          </a:prstGeom>
+        </p:spPr>
+      </p:pic>
+      <p:pic>
+        <p:nvPicPr>
+          <p:cNvPr id="61" name="Picture 60" descr="A group of squares on a gray background&#10;&#10;Description automatically generated">
+            <a:extLst>
+              <a:ext uri="{FF2B5EF4-FFF2-40B4-BE49-F238E27FC236}">
+                <a16:creationId xmlns:a16="http://schemas.microsoft.com/office/drawing/2014/main" id="{1D09B190-FCF9-4A4A-1CA6-6519F35FF252}"/>
+              </a:ext>
+            </a:extLst>
+          </p:cNvPr>
+          <p:cNvPicPr>
+            <a:picLocks noChangeAspect="1"/>
+          </p:cNvPicPr>
+          <p:nvPr/>
+        </p:nvPicPr>
+        <p:blipFill>
+          <a:blip r:embed="rId3"/>
+          <a:stretch>
+            <a:fillRect/>
+          </a:stretch>
+        </p:blipFill>
+        <p:spPr>
+          <a:xfrm>
+            <a:off x="3147213" y="474239"/>
+            <a:ext cx="2525504" cy="2565276"/>
+          </a:xfrm>
+          <a:prstGeom prst="rect">
+            <a:avLst/>
+          </a:prstGeom>
+        </p:spPr>
+      </p:pic>
+      <p:pic>
+        <p:nvPicPr>
+          <p:cNvPr id="4" name="Picture 3" descr="A group of squares on a gray background&#10;&#10;Description automatically generated">
+            <a:extLst>
+              <a:ext uri="{FF2B5EF4-FFF2-40B4-BE49-F238E27FC236}">
+                <a16:creationId xmlns:a16="http://schemas.microsoft.com/office/drawing/2014/main" id="{CDDB8A89-0991-40D8-6657-B7FE485A4A85}"/>
+              </a:ext>
+            </a:extLst>
+          </p:cNvPr>
+          <p:cNvPicPr>
+            <a:picLocks noChangeAspect="1"/>
+          </p:cNvPicPr>
+          <p:nvPr/>
+        </p:nvPicPr>
+        <p:blipFill>
+          <a:blip r:embed="rId3"/>
+          <a:stretch>
+            <a:fillRect/>
+          </a:stretch>
+        </p:blipFill>
+        <p:spPr>
+          <a:xfrm>
+            <a:off x="224171" y="474239"/>
+            <a:ext cx="2525504" cy="2565276"/>
+          </a:xfrm>
+          <a:prstGeom prst="rect">
+            <a:avLst/>
+          </a:prstGeom>
+        </p:spPr>
+      </p:pic>
+      <p:sp>
+        <p:nvSpPr>
+          <p:cNvPr id="8" name="TextBox 7">
+            <a:extLst>
+              <a:ext uri="{FF2B5EF4-FFF2-40B4-BE49-F238E27FC236}">
+                <a16:creationId xmlns:a16="http://schemas.microsoft.com/office/drawing/2014/main" id="{F6BAAC84-2568-5C49-8BA5-028A0048DAEE}"/>
+              </a:ext>
+            </a:extLst>
+          </p:cNvPr>
+          <p:cNvSpPr txBox="1"/>
+          <p:nvPr/>
+        </p:nvSpPr>
+        <p:spPr>
+          <a:xfrm>
+            <a:off x="3416914" y="79438"/>
+            <a:ext cx="1847557" cy="369332"/>
+          </a:xfrm>
+          <a:prstGeom prst="rect">
+            <a:avLst/>
+          </a:prstGeom>
+          <a:noFill/>
+        </p:spPr>
+        <p:txBody>
+          <a:bodyPr wrap="none" rtlCol="0">
+            <a:spAutoFit/>
+          </a:bodyPr>
+          <a:lstStyle/>
+          <a:p>
+            <a:r>
+              <a:rPr lang="en-US" dirty="0"/>
+              <a:t>Stick/Switch (b</a:t>
+            </a:r>
+            <a:r>
+              <a:rPr lang="en-US" baseline="-25000" dirty="0"/>
+              <a:t>s</a:t>
+            </a:r>
+            <a:r>
+              <a:rPr lang="en-US" dirty="0"/>
+              <a:t>)</a:t>
+            </a:r>
+          </a:p>
+        </p:txBody>
+      </p:sp>
+      <p:sp>
+        <p:nvSpPr>
+          <p:cNvPr id="9" name="TextBox 8">
+            <a:extLst>
+              <a:ext uri="{FF2B5EF4-FFF2-40B4-BE49-F238E27FC236}">
+                <a16:creationId xmlns:a16="http://schemas.microsoft.com/office/drawing/2014/main" id="{543481BB-502C-6951-BCE2-D0D4111CBE5B}"/>
+              </a:ext>
+            </a:extLst>
+          </p:cNvPr>
+          <p:cNvSpPr txBox="1"/>
+          <p:nvPr/>
+        </p:nvSpPr>
+        <p:spPr>
+          <a:xfrm>
+            <a:off x="472531" y="79438"/>
+            <a:ext cx="2127698" cy="369332"/>
+          </a:xfrm>
+          <a:prstGeom prst="rect">
+            <a:avLst/>
+          </a:prstGeom>
+          <a:noFill/>
+        </p:spPr>
+        <p:txBody>
+          <a:bodyPr wrap="none" rtlCol="0">
+            <a:spAutoFit/>
+          </a:bodyPr>
+          <a:lstStyle/>
+          <a:p>
+            <a:r>
+              <a:rPr lang="en-US" dirty="0"/>
+              <a:t>Class weights (b</a:t>
+            </a:r>
+            <a:r>
+              <a:rPr lang="en-US" baseline="-25000" dirty="0"/>
+              <a:t>AvB</a:t>
+            </a:r>
+            <a:r>
+              <a:rPr lang="en-US" dirty="0"/>
+              <a:t>)</a:t>
+            </a:r>
+          </a:p>
+        </p:txBody>
+      </p:sp>
+      <p:sp>
+        <p:nvSpPr>
+          <p:cNvPr id="10" name="TextBox 9">
+            <a:extLst>
+              <a:ext uri="{FF2B5EF4-FFF2-40B4-BE49-F238E27FC236}">
+                <a16:creationId xmlns:a16="http://schemas.microsoft.com/office/drawing/2014/main" id="{86BD5FDC-76D5-6A3A-2795-F2E729E7A9DC}"/>
+              </a:ext>
+            </a:extLst>
+          </p:cNvPr>
+          <p:cNvSpPr txBox="1"/>
+          <p:nvPr/>
+        </p:nvSpPr>
+        <p:spPr>
+          <a:xfrm>
+            <a:off x="6539453" y="1860284"/>
+            <a:ext cx="1538113" cy="369332"/>
+          </a:xfrm>
+          <a:prstGeom prst="rect">
+            <a:avLst/>
+          </a:prstGeom>
+          <a:noFill/>
+        </p:spPr>
+        <p:txBody>
+          <a:bodyPr wrap="none" rtlCol="0">
+            <a:spAutoFit/>
+          </a:bodyPr>
+          <a:lstStyle/>
+          <a:p>
+            <a:r>
+              <a:rPr lang="en-US" dirty="0"/>
+              <a:t>Proximity (</a:t>
+            </a:r>
+            <a:r>
+              <a:rPr lang="el-GR" dirty="0"/>
+              <a:t>ρ</a:t>
+            </a:r>
+            <a:r>
+              <a:rPr lang="el-GR" baseline="-25000" dirty="0"/>
+              <a:t>δ</a:t>
+            </a:r>
+            <a:r>
+              <a:rPr lang="en-GB" dirty="0"/>
+              <a:t>)</a:t>
+            </a:r>
+            <a:endParaRPr lang="en-US" dirty="0"/>
+          </a:p>
+        </p:txBody>
+      </p:sp>
+      <p:sp>
+        <p:nvSpPr>
+          <p:cNvPr id="11" name="TextBox 10">
+            <a:extLst>
+              <a:ext uri="{FF2B5EF4-FFF2-40B4-BE49-F238E27FC236}">
+                <a16:creationId xmlns:a16="http://schemas.microsoft.com/office/drawing/2014/main" id="{3A773B8E-C7C0-ECE0-8694-ECA21442FFB7}"/>
+              </a:ext>
+            </a:extLst>
+          </p:cNvPr>
+          <p:cNvSpPr txBox="1"/>
+          <p:nvPr/>
+        </p:nvSpPr>
+        <p:spPr>
+          <a:xfrm>
+            <a:off x="715641" y="3488091"/>
+            <a:ext cx="1516825" cy="369332"/>
+          </a:xfrm>
+          <a:prstGeom prst="rect">
+            <a:avLst/>
+          </a:prstGeom>
+          <a:noFill/>
+        </p:spPr>
+        <p:txBody>
+          <a:bodyPr wrap="none" rtlCol="0">
+            <a:spAutoFit/>
+          </a:bodyPr>
+          <a:lstStyle/>
+          <a:p>
+            <a:r>
+              <a:rPr lang="en-US" dirty="0"/>
+              <a:t>Direction (</a:t>
+            </a:r>
+            <a:r>
+              <a:rPr lang="el-GR" dirty="0"/>
+              <a:t>ρ</a:t>
+            </a:r>
+            <a:r>
+              <a:rPr lang="el-GR" baseline="-25000" dirty="0"/>
+              <a:t>ψ</a:t>
+            </a:r>
+            <a:r>
+              <a:rPr lang="el-GR" dirty="0"/>
+              <a:t>)</a:t>
+            </a:r>
+            <a:endParaRPr lang="en-US" dirty="0"/>
+          </a:p>
+        </p:txBody>
+      </p:sp>
+      <p:cxnSp>
+        <p:nvCxnSpPr>
+          <p:cNvPr id="12" name="Straight Arrow Connector 11">
+            <a:extLst>
+              <a:ext uri="{FF2B5EF4-FFF2-40B4-BE49-F238E27FC236}">
+                <a16:creationId xmlns:a16="http://schemas.microsoft.com/office/drawing/2014/main" id="{9FB419ED-6276-7A5C-5522-F28D43F539C7}"/>
+              </a:ext>
+            </a:extLst>
+          </p:cNvPr>
+          <p:cNvCxnSpPr>
+            <a:cxnSpLocks/>
+          </p:cNvCxnSpPr>
+          <p:nvPr/>
+        </p:nvCxnSpPr>
+        <p:spPr>
+          <a:xfrm>
+            <a:off x="3344118" y="1079719"/>
+            <a:ext cx="547586" cy="592391"/>
+          </a:xfrm>
+          <a:prstGeom prst="straightConnector1">
+            <a:avLst/>
+          </a:prstGeom>
+          <a:ln w="47625">
+            <a:solidFill>
+              <a:srgbClr val="FF0000"/>
+            </a:solidFill>
+            <a:tailEnd type="triangle"/>
+          </a:ln>
+        </p:spPr>
+        <p:style>
+          <a:lnRef idx="2">
+            <a:schemeClr val="dk1"/>
+          </a:lnRef>
+          <a:fillRef idx="0">
+            <a:schemeClr val="dk1"/>
+          </a:fillRef>
+          <a:effectRef idx="1">
+            <a:schemeClr val="dk1"/>
+          </a:effectRef>
+          <a:fontRef idx="minor">
+            <a:schemeClr val="tx1"/>
+          </a:fontRef>
+        </p:style>
+      </p:cxnSp>
+      <p:cxnSp>
+        <p:nvCxnSpPr>
+          <p:cNvPr id="13" name="Straight Arrow Connector 12">
+            <a:extLst>
+              <a:ext uri="{FF2B5EF4-FFF2-40B4-BE49-F238E27FC236}">
+                <a16:creationId xmlns:a16="http://schemas.microsoft.com/office/drawing/2014/main" id="{79F539AC-C08D-EEF7-5B01-9670A8AFD63D}"/>
+              </a:ext>
+            </a:extLst>
+          </p:cNvPr>
+          <p:cNvCxnSpPr>
+            <a:cxnSpLocks/>
+          </p:cNvCxnSpPr>
+          <p:nvPr/>
+        </p:nvCxnSpPr>
+        <p:spPr>
+          <a:xfrm>
+            <a:off x="4104383" y="1822865"/>
+            <a:ext cx="584217" cy="277257"/>
+          </a:xfrm>
+          <a:prstGeom prst="straightConnector1">
+            <a:avLst/>
+          </a:prstGeom>
+          <a:ln w="47625">
+            <a:solidFill>
+              <a:srgbClr val="FF0000"/>
+            </a:solidFill>
+            <a:tailEnd type="triangle"/>
+          </a:ln>
+        </p:spPr>
+        <p:style>
+          <a:lnRef idx="2">
+            <a:schemeClr val="dk1"/>
+          </a:lnRef>
+          <a:fillRef idx="0">
+            <a:schemeClr val="dk1"/>
+          </a:fillRef>
+          <a:effectRef idx="1">
+            <a:schemeClr val="dk1"/>
+          </a:effectRef>
+          <a:fontRef idx="minor">
+            <a:schemeClr val="tx1"/>
+          </a:fontRef>
+        </p:style>
+      </p:cxnSp>
+      <p:cxnSp>
+        <p:nvCxnSpPr>
+          <p:cNvPr id="14" name="Straight Arrow Connector 13">
+            <a:extLst>
+              <a:ext uri="{FF2B5EF4-FFF2-40B4-BE49-F238E27FC236}">
+                <a16:creationId xmlns:a16="http://schemas.microsoft.com/office/drawing/2014/main" id="{73C5FD00-4E74-BA18-6AA0-24E188EA6144}"/>
+              </a:ext>
+            </a:extLst>
+          </p:cNvPr>
+          <p:cNvCxnSpPr>
+            <a:cxnSpLocks/>
+          </p:cNvCxnSpPr>
+          <p:nvPr/>
+        </p:nvCxnSpPr>
+        <p:spPr>
+          <a:xfrm>
+            <a:off x="5176196" y="740089"/>
+            <a:ext cx="303960" cy="276212"/>
+          </a:xfrm>
+          <a:prstGeom prst="straightConnector1">
+            <a:avLst/>
+          </a:prstGeom>
+          <a:ln w="47625">
+            <a:solidFill>
+              <a:schemeClr val="accent3">
+                <a:lumMod val="60000"/>
+                <a:lumOff val="40000"/>
+              </a:schemeClr>
+            </a:solidFill>
+            <a:tailEnd type="triangle"/>
+          </a:ln>
+        </p:spPr>
+        <p:style>
+          <a:lnRef idx="2">
+            <a:schemeClr val="dk1"/>
+          </a:lnRef>
+          <a:fillRef idx="0">
+            <a:schemeClr val="dk1"/>
+          </a:fillRef>
+          <a:effectRef idx="1">
+            <a:schemeClr val="dk1"/>
+          </a:effectRef>
+          <a:fontRef idx="minor">
+            <a:schemeClr val="tx1"/>
+          </a:fontRef>
+        </p:style>
+      </p:cxnSp>
+      <p:cxnSp>
+        <p:nvCxnSpPr>
+          <p:cNvPr id="15" name="Straight Arrow Connector 14">
+            <a:extLst>
+              <a:ext uri="{FF2B5EF4-FFF2-40B4-BE49-F238E27FC236}">
+                <a16:creationId xmlns:a16="http://schemas.microsoft.com/office/drawing/2014/main" id="{791D9CDB-1E2F-0AC6-3DD7-881B4D35946D}"/>
+              </a:ext>
+            </a:extLst>
+          </p:cNvPr>
+          <p:cNvCxnSpPr>
+            <a:cxnSpLocks/>
+          </p:cNvCxnSpPr>
+          <p:nvPr/>
+        </p:nvCxnSpPr>
+        <p:spPr>
+          <a:xfrm>
+            <a:off x="5480156" y="1166747"/>
+            <a:ext cx="0" cy="207227"/>
+          </a:xfrm>
+          <a:prstGeom prst="straightConnector1">
+            <a:avLst/>
+          </a:prstGeom>
+          <a:ln w="47625">
+            <a:solidFill>
+              <a:schemeClr val="accent3">
+                <a:lumMod val="60000"/>
+                <a:lumOff val="40000"/>
+              </a:schemeClr>
+            </a:solidFill>
+            <a:tailEnd type="triangle"/>
+          </a:ln>
+        </p:spPr>
+        <p:style>
+          <a:lnRef idx="2">
+            <a:schemeClr val="dk1"/>
+          </a:lnRef>
+          <a:fillRef idx="0">
+            <a:schemeClr val="dk1"/>
+          </a:fillRef>
+          <a:effectRef idx="1">
+            <a:schemeClr val="dk1"/>
+          </a:effectRef>
+          <a:fontRef idx="minor">
+            <a:schemeClr val="tx1"/>
+          </a:fontRef>
+        </p:style>
+      </p:cxnSp>
+      <p:cxnSp>
+        <p:nvCxnSpPr>
+          <p:cNvPr id="16" name="Straight Arrow Connector 15">
+            <a:extLst>
+              <a:ext uri="{FF2B5EF4-FFF2-40B4-BE49-F238E27FC236}">
+                <a16:creationId xmlns:a16="http://schemas.microsoft.com/office/drawing/2014/main" id="{E7AA43C7-08E9-E15B-50A9-F43D14DD7689}"/>
+              </a:ext>
+            </a:extLst>
+          </p:cNvPr>
+          <p:cNvCxnSpPr>
+            <a:cxnSpLocks/>
+          </p:cNvCxnSpPr>
+          <p:nvPr/>
+        </p:nvCxnSpPr>
+        <p:spPr>
+          <a:xfrm>
+            <a:off x="5468169" y="1473868"/>
+            <a:ext cx="8337" cy="249450"/>
+          </a:xfrm>
+          <a:prstGeom prst="straightConnector1">
+            <a:avLst/>
+          </a:prstGeom>
+          <a:ln w="47625">
+            <a:solidFill>
+              <a:schemeClr val="accent3">
+                <a:lumMod val="60000"/>
+                <a:lumOff val="40000"/>
+              </a:schemeClr>
+            </a:solidFill>
+            <a:tailEnd type="triangle"/>
+          </a:ln>
+        </p:spPr>
+        <p:style>
+          <a:lnRef idx="2">
+            <a:schemeClr val="dk1"/>
+          </a:lnRef>
+          <a:fillRef idx="0">
+            <a:schemeClr val="dk1"/>
+          </a:fillRef>
+          <a:effectRef idx="1">
+            <a:schemeClr val="dk1"/>
+          </a:effectRef>
+          <a:fontRef idx="minor">
+            <a:schemeClr val="tx1"/>
+          </a:fontRef>
+        </p:style>
+      </p:cxnSp>
+      <p:cxnSp>
+        <p:nvCxnSpPr>
+          <p:cNvPr id="17" name="Straight Arrow Connector 16">
+            <a:extLst>
+              <a:ext uri="{FF2B5EF4-FFF2-40B4-BE49-F238E27FC236}">
+                <a16:creationId xmlns:a16="http://schemas.microsoft.com/office/drawing/2014/main" id="{6FC72DCC-BB05-6A62-F8D3-18A7ED9023BF}"/>
+              </a:ext>
+            </a:extLst>
+          </p:cNvPr>
+          <p:cNvCxnSpPr>
+            <a:cxnSpLocks/>
+          </p:cNvCxnSpPr>
+          <p:nvPr/>
+        </p:nvCxnSpPr>
+        <p:spPr>
+          <a:xfrm>
+            <a:off x="3752892" y="3168648"/>
+            <a:ext cx="423217" cy="0"/>
+          </a:xfrm>
+          <a:prstGeom prst="straightConnector1">
+            <a:avLst/>
+          </a:prstGeom>
+          <a:ln w="47625">
+            <a:solidFill>
+              <a:schemeClr val="accent3">
+                <a:lumMod val="60000"/>
+                <a:lumOff val="40000"/>
+              </a:schemeClr>
+            </a:solidFill>
+            <a:tailEnd type="triangle"/>
+          </a:ln>
+        </p:spPr>
+        <p:style>
+          <a:lnRef idx="2">
+            <a:schemeClr val="dk1"/>
+          </a:lnRef>
+          <a:fillRef idx="0">
+            <a:schemeClr val="dk1"/>
+          </a:fillRef>
+          <a:effectRef idx="1">
+            <a:schemeClr val="dk1"/>
+          </a:effectRef>
+          <a:fontRef idx="minor">
+            <a:schemeClr val="tx1"/>
+          </a:fontRef>
+        </p:style>
+      </p:cxnSp>
+      <p:cxnSp>
+        <p:nvCxnSpPr>
+          <p:cNvPr id="18" name="Straight Arrow Connector 17">
+            <a:extLst>
+              <a:ext uri="{FF2B5EF4-FFF2-40B4-BE49-F238E27FC236}">
+                <a16:creationId xmlns:a16="http://schemas.microsoft.com/office/drawing/2014/main" id="{17EA0E3F-6B2B-033A-D046-4E39E017348A}"/>
+              </a:ext>
+            </a:extLst>
+          </p:cNvPr>
+          <p:cNvCxnSpPr>
+            <a:cxnSpLocks/>
+          </p:cNvCxnSpPr>
+          <p:nvPr/>
+        </p:nvCxnSpPr>
+        <p:spPr>
+          <a:xfrm>
+            <a:off x="3762127" y="3355273"/>
+            <a:ext cx="423217" cy="0"/>
+          </a:xfrm>
+          <a:prstGeom prst="straightConnector1">
+            <a:avLst/>
+          </a:prstGeom>
+          <a:ln w="47625">
+            <a:solidFill>
+              <a:srgbClr val="FF0000"/>
+            </a:solidFill>
+            <a:tailEnd type="triangle"/>
+          </a:ln>
+        </p:spPr>
+        <p:style>
+          <a:lnRef idx="2">
+            <a:schemeClr val="dk1"/>
+          </a:lnRef>
+          <a:fillRef idx="0">
+            <a:schemeClr val="dk1"/>
+          </a:fillRef>
+          <a:effectRef idx="1">
+            <a:schemeClr val="dk1"/>
+          </a:effectRef>
+          <a:fontRef idx="minor">
+            <a:schemeClr val="tx1"/>
+          </a:fontRef>
+        </p:style>
+      </p:cxnSp>
+      <p:sp>
+        <p:nvSpPr>
+          <p:cNvPr id="19" name="TextBox 18">
+            <a:extLst>
+              <a:ext uri="{FF2B5EF4-FFF2-40B4-BE49-F238E27FC236}">
+                <a16:creationId xmlns:a16="http://schemas.microsoft.com/office/drawing/2014/main" id="{C2626AE0-77A7-7AE4-DED5-2D2D5CC7AB55}"/>
+              </a:ext>
+            </a:extLst>
+          </p:cNvPr>
+          <p:cNvSpPr txBox="1"/>
+          <p:nvPr/>
+        </p:nvSpPr>
+        <p:spPr>
+          <a:xfrm>
+            <a:off x="4176109" y="3035109"/>
+            <a:ext cx="957891" cy="461665"/>
+          </a:xfrm>
+          <a:prstGeom prst="rect">
+            <a:avLst/>
+          </a:prstGeom>
+          <a:noFill/>
+        </p:spPr>
+        <p:txBody>
+          <a:bodyPr wrap="none" rtlCol="0">
+            <a:spAutoFit/>
+          </a:bodyPr>
+          <a:lstStyle/>
+          <a:p>
+            <a:r>
+              <a:rPr lang="en-US" sz="1200" dirty="0"/>
+              <a:t>High switch</a:t>
+            </a:r>
+          </a:p>
+          <a:p>
+            <a:r>
+              <a:rPr lang="en-US" sz="1200" dirty="0"/>
+              <a:t>High Stick</a:t>
+            </a:r>
+          </a:p>
+        </p:txBody>
+      </p:sp>
+      <p:cxnSp>
+        <p:nvCxnSpPr>
+          <p:cNvPr id="20" name="Straight Arrow Connector 19">
+            <a:extLst>
+              <a:ext uri="{FF2B5EF4-FFF2-40B4-BE49-F238E27FC236}">
+                <a16:creationId xmlns:a16="http://schemas.microsoft.com/office/drawing/2014/main" id="{38B78676-81D7-2D12-3381-F60D0AACB2D5}"/>
+              </a:ext>
+            </a:extLst>
+          </p:cNvPr>
+          <p:cNvCxnSpPr>
+            <a:cxnSpLocks/>
+          </p:cNvCxnSpPr>
+          <p:nvPr/>
+        </p:nvCxnSpPr>
+        <p:spPr>
+          <a:xfrm>
+            <a:off x="441329" y="640920"/>
+            <a:ext cx="263628" cy="67006"/>
+          </a:xfrm>
+          <a:prstGeom prst="straightConnector1">
+            <a:avLst/>
+          </a:prstGeom>
+          <a:ln w="47625">
+            <a:solidFill>
+              <a:srgbClr val="FF0000"/>
+            </a:solidFill>
+            <a:tailEnd type="triangle"/>
+          </a:ln>
+        </p:spPr>
+        <p:style>
+          <a:lnRef idx="2">
+            <a:schemeClr val="dk1"/>
+          </a:lnRef>
+          <a:fillRef idx="0">
+            <a:schemeClr val="dk1"/>
+          </a:fillRef>
+          <a:effectRef idx="1">
+            <a:schemeClr val="dk1"/>
+          </a:effectRef>
+          <a:fontRef idx="minor">
+            <a:schemeClr val="tx1"/>
+          </a:fontRef>
+        </p:style>
+      </p:cxnSp>
+      <p:cxnSp>
+        <p:nvCxnSpPr>
+          <p:cNvPr id="21" name="Straight Arrow Connector 20">
+            <a:extLst>
+              <a:ext uri="{FF2B5EF4-FFF2-40B4-BE49-F238E27FC236}">
+                <a16:creationId xmlns:a16="http://schemas.microsoft.com/office/drawing/2014/main" id="{6E6DAEF2-0DB7-6A2E-7D6E-7FE37B62F5E8}"/>
+              </a:ext>
+            </a:extLst>
+          </p:cNvPr>
+          <p:cNvCxnSpPr>
+            <a:cxnSpLocks/>
+          </p:cNvCxnSpPr>
+          <p:nvPr/>
+        </p:nvCxnSpPr>
+        <p:spPr>
+          <a:xfrm flipH="1">
+            <a:off x="426577" y="787932"/>
+            <a:ext cx="295414" cy="205846"/>
+          </a:xfrm>
+          <a:prstGeom prst="straightConnector1">
+            <a:avLst/>
+          </a:prstGeom>
+          <a:ln w="47625">
+            <a:solidFill>
+              <a:srgbClr val="FF0000"/>
+            </a:solidFill>
+            <a:tailEnd type="triangle"/>
+          </a:ln>
+        </p:spPr>
+        <p:style>
+          <a:lnRef idx="2">
+            <a:schemeClr val="dk1"/>
+          </a:lnRef>
+          <a:fillRef idx="0">
+            <a:schemeClr val="dk1"/>
+          </a:fillRef>
+          <a:effectRef idx="1">
+            <a:schemeClr val="dk1"/>
+          </a:effectRef>
+          <a:fontRef idx="minor">
+            <a:schemeClr val="tx1"/>
+          </a:fontRef>
+        </p:style>
+      </p:cxnSp>
+      <p:cxnSp>
+        <p:nvCxnSpPr>
+          <p:cNvPr id="22" name="Straight Arrow Connector 21">
+            <a:extLst>
+              <a:ext uri="{FF2B5EF4-FFF2-40B4-BE49-F238E27FC236}">
+                <a16:creationId xmlns:a16="http://schemas.microsoft.com/office/drawing/2014/main" id="{D558D86E-EFE2-2730-62B2-87524150E2E1}"/>
+              </a:ext>
+            </a:extLst>
+          </p:cNvPr>
+          <p:cNvCxnSpPr>
+            <a:cxnSpLocks/>
+          </p:cNvCxnSpPr>
+          <p:nvPr/>
+        </p:nvCxnSpPr>
+        <p:spPr>
+          <a:xfrm>
+            <a:off x="2288209" y="1098191"/>
+            <a:ext cx="234443" cy="0"/>
+          </a:xfrm>
+          <a:prstGeom prst="straightConnector1">
+            <a:avLst/>
+          </a:prstGeom>
+          <a:ln w="47625">
+            <a:solidFill>
+              <a:schemeClr val="accent3">
+                <a:lumMod val="60000"/>
+                <a:lumOff val="40000"/>
+              </a:schemeClr>
+            </a:solidFill>
+            <a:tailEnd type="triangle"/>
+          </a:ln>
+        </p:spPr>
+        <p:style>
+          <a:lnRef idx="2">
+            <a:schemeClr val="dk1"/>
+          </a:lnRef>
+          <a:fillRef idx="0">
+            <a:schemeClr val="dk1"/>
+          </a:fillRef>
+          <a:effectRef idx="1">
+            <a:schemeClr val="dk1"/>
+          </a:effectRef>
+          <a:fontRef idx="minor">
+            <a:schemeClr val="tx1"/>
+          </a:fontRef>
+        </p:style>
+      </p:cxnSp>
+      <p:cxnSp>
+        <p:nvCxnSpPr>
+          <p:cNvPr id="23" name="Straight Arrow Connector 22">
+            <a:extLst>
+              <a:ext uri="{FF2B5EF4-FFF2-40B4-BE49-F238E27FC236}">
+                <a16:creationId xmlns:a16="http://schemas.microsoft.com/office/drawing/2014/main" id="{F718337B-0CBE-E85F-6ED7-A72675ACF64D}"/>
+              </a:ext>
+            </a:extLst>
+          </p:cNvPr>
+          <p:cNvCxnSpPr>
+            <a:cxnSpLocks/>
+          </p:cNvCxnSpPr>
+          <p:nvPr/>
+        </p:nvCxnSpPr>
+        <p:spPr>
+          <a:xfrm>
+            <a:off x="1606872" y="707926"/>
+            <a:ext cx="455257" cy="332031"/>
+          </a:xfrm>
+          <a:prstGeom prst="straightConnector1">
+            <a:avLst/>
+          </a:prstGeom>
+          <a:ln w="47625">
+            <a:solidFill>
+              <a:schemeClr val="accent3">
+                <a:lumMod val="60000"/>
+                <a:lumOff val="40000"/>
+              </a:schemeClr>
+            </a:solidFill>
+            <a:tailEnd type="triangle"/>
+          </a:ln>
+        </p:spPr>
+        <p:style>
+          <a:lnRef idx="2">
+            <a:schemeClr val="dk1"/>
+          </a:lnRef>
+          <a:fillRef idx="0">
+            <a:schemeClr val="dk1"/>
+          </a:fillRef>
+          <a:effectRef idx="1">
+            <a:schemeClr val="dk1"/>
+          </a:effectRef>
+          <a:fontRef idx="minor">
+            <a:schemeClr val="tx1"/>
+          </a:fontRef>
+        </p:style>
+      </p:cxnSp>
+      <p:cxnSp>
+        <p:nvCxnSpPr>
+          <p:cNvPr id="24" name="Straight Arrow Connector 23">
+            <a:extLst>
+              <a:ext uri="{FF2B5EF4-FFF2-40B4-BE49-F238E27FC236}">
+                <a16:creationId xmlns:a16="http://schemas.microsoft.com/office/drawing/2014/main" id="{00BDF9EE-0802-61C9-2508-E1355941139E}"/>
+              </a:ext>
+            </a:extLst>
+          </p:cNvPr>
+          <p:cNvCxnSpPr>
+            <a:cxnSpLocks/>
+          </p:cNvCxnSpPr>
+          <p:nvPr/>
+        </p:nvCxnSpPr>
+        <p:spPr>
+          <a:xfrm>
+            <a:off x="598036" y="3140567"/>
+            <a:ext cx="423217" cy="0"/>
+          </a:xfrm>
+          <a:prstGeom prst="straightConnector1">
+            <a:avLst/>
+          </a:prstGeom>
+          <a:ln w="47625">
+            <a:solidFill>
+              <a:schemeClr val="accent3">
+                <a:lumMod val="60000"/>
+                <a:lumOff val="40000"/>
+              </a:schemeClr>
+            </a:solidFill>
+            <a:tailEnd type="triangle"/>
+          </a:ln>
+        </p:spPr>
+        <p:style>
+          <a:lnRef idx="2">
+            <a:schemeClr val="dk1"/>
+          </a:lnRef>
+          <a:fillRef idx="0">
+            <a:schemeClr val="dk1"/>
+          </a:fillRef>
+          <a:effectRef idx="1">
+            <a:schemeClr val="dk1"/>
+          </a:effectRef>
+          <a:fontRef idx="minor">
+            <a:schemeClr val="tx1"/>
+          </a:fontRef>
+        </p:style>
+      </p:cxnSp>
+      <p:cxnSp>
+        <p:nvCxnSpPr>
+          <p:cNvPr id="25" name="Straight Arrow Connector 24">
+            <a:extLst>
+              <a:ext uri="{FF2B5EF4-FFF2-40B4-BE49-F238E27FC236}">
+                <a16:creationId xmlns:a16="http://schemas.microsoft.com/office/drawing/2014/main" id="{65A46472-2FAD-9C89-023C-05C7F89AA1E6}"/>
+              </a:ext>
+            </a:extLst>
+          </p:cNvPr>
+          <p:cNvCxnSpPr>
+            <a:cxnSpLocks/>
+          </p:cNvCxnSpPr>
+          <p:nvPr/>
+        </p:nvCxnSpPr>
+        <p:spPr>
+          <a:xfrm>
+            <a:off x="598036" y="3334162"/>
+            <a:ext cx="423217" cy="0"/>
+          </a:xfrm>
+          <a:prstGeom prst="straightConnector1">
+            <a:avLst/>
+          </a:prstGeom>
+          <a:ln w="47625">
+            <a:solidFill>
+              <a:srgbClr val="FF0000"/>
+            </a:solidFill>
+            <a:tailEnd type="triangle"/>
+          </a:ln>
+        </p:spPr>
+        <p:style>
+          <a:lnRef idx="2">
+            <a:schemeClr val="dk1"/>
+          </a:lnRef>
+          <a:fillRef idx="0">
+            <a:schemeClr val="dk1"/>
+          </a:fillRef>
+          <a:effectRef idx="1">
+            <a:schemeClr val="dk1"/>
+          </a:effectRef>
+          <a:fontRef idx="minor">
+            <a:schemeClr val="tx1"/>
+          </a:fontRef>
+        </p:style>
+      </p:cxnSp>
+      <p:sp>
+        <p:nvSpPr>
+          <p:cNvPr id="26" name="TextBox 25">
+            <a:extLst>
+              <a:ext uri="{FF2B5EF4-FFF2-40B4-BE49-F238E27FC236}">
+                <a16:creationId xmlns:a16="http://schemas.microsoft.com/office/drawing/2014/main" id="{2424540B-908A-161E-9FC0-850A79538FFD}"/>
+              </a:ext>
+            </a:extLst>
+          </p:cNvPr>
+          <p:cNvSpPr txBox="1"/>
+          <p:nvPr/>
+        </p:nvSpPr>
+        <p:spPr>
+          <a:xfrm>
+            <a:off x="1009371" y="3017498"/>
+            <a:ext cx="1650260" cy="461665"/>
+          </a:xfrm>
+          <a:prstGeom prst="rect">
+            <a:avLst/>
+          </a:prstGeom>
+          <a:noFill/>
+        </p:spPr>
+        <p:txBody>
+          <a:bodyPr wrap="none" rtlCol="0">
+            <a:spAutoFit/>
+          </a:bodyPr>
+          <a:lstStyle/>
+          <a:p>
+            <a:r>
+              <a:rPr lang="en-US" sz="1200" dirty="0"/>
+              <a:t>Preference for target 1</a:t>
+            </a:r>
+          </a:p>
+          <a:p>
+            <a:r>
+              <a:rPr lang="en-US" sz="1200" dirty="0"/>
+              <a:t>Preference for target 2</a:t>
+            </a:r>
+          </a:p>
+        </p:txBody>
+      </p:sp>
+      <p:cxnSp>
+        <p:nvCxnSpPr>
+          <p:cNvPr id="27" name="Straight Arrow Connector 26">
+            <a:extLst>
+              <a:ext uri="{FF2B5EF4-FFF2-40B4-BE49-F238E27FC236}">
+                <a16:creationId xmlns:a16="http://schemas.microsoft.com/office/drawing/2014/main" id="{D4435E05-1D11-80A3-65DC-6627DF972102}"/>
+              </a:ext>
+            </a:extLst>
+          </p:cNvPr>
+          <p:cNvCxnSpPr>
+            <a:cxnSpLocks/>
+          </p:cNvCxnSpPr>
+          <p:nvPr/>
+        </p:nvCxnSpPr>
+        <p:spPr>
+          <a:xfrm>
+            <a:off x="411062" y="4034413"/>
+            <a:ext cx="324161" cy="78043"/>
+          </a:xfrm>
+          <a:prstGeom prst="straightConnector1">
+            <a:avLst/>
+          </a:prstGeom>
+          <a:ln w="47625">
+            <a:solidFill>
+              <a:schemeClr val="accent3">
+                <a:lumMod val="60000"/>
+                <a:lumOff val="40000"/>
+              </a:schemeClr>
+            </a:solidFill>
+            <a:tailEnd type="triangle"/>
+          </a:ln>
+        </p:spPr>
+        <p:style>
+          <a:lnRef idx="2">
+            <a:schemeClr val="dk1"/>
+          </a:lnRef>
+          <a:fillRef idx="0">
+            <a:schemeClr val="dk1"/>
+          </a:fillRef>
+          <a:effectRef idx="1">
+            <a:schemeClr val="dk1"/>
+          </a:effectRef>
+          <a:fontRef idx="minor">
+            <a:schemeClr val="tx1"/>
+          </a:fontRef>
+        </p:style>
+      </p:cxnSp>
+      <p:cxnSp>
+        <p:nvCxnSpPr>
+          <p:cNvPr id="28" name="Straight Arrow Connector 27">
+            <a:extLst>
+              <a:ext uri="{FF2B5EF4-FFF2-40B4-BE49-F238E27FC236}">
+                <a16:creationId xmlns:a16="http://schemas.microsoft.com/office/drawing/2014/main" id="{7588A5DE-4CF2-AAAE-6EC9-C090C96DEFBA}"/>
+              </a:ext>
+            </a:extLst>
+          </p:cNvPr>
+          <p:cNvCxnSpPr>
+            <a:cxnSpLocks/>
+          </p:cNvCxnSpPr>
+          <p:nvPr/>
+        </p:nvCxnSpPr>
+        <p:spPr>
+          <a:xfrm flipV="1">
+            <a:off x="7272724" y="3135163"/>
+            <a:ext cx="0" cy="245226"/>
+          </a:xfrm>
+          <a:prstGeom prst="straightConnector1">
+            <a:avLst/>
+          </a:prstGeom>
+          <a:ln w="47625">
+            <a:solidFill>
+              <a:srgbClr val="FF0000"/>
+            </a:solidFill>
+            <a:tailEnd type="triangle"/>
+          </a:ln>
+        </p:spPr>
+        <p:style>
+          <a:lnRef idx="2">
+            <a:schemeClr val="dk1"/>
+          </a:lnRef>
+          <a:fillRef idx="0">
+            <a:schemeClr val="dk1"/>
+          </a:fillRef>
+          <a:effectRef idx="1">
+            <a:schemeClr val="dk1"/>
+          </a:effectRef>
+          <a:fontRef idx="minor">
+            <a:schemeClr val="tx1"/>
+          </a:fontRef>
+        </p:style>
+      </p:cxnSp>
+      <p:cxnSp>
+        <p:nvCxnSpPr>
+          <p:cNvPr id="29" name="Straight Arrow Connector 28">
+            <a:extLst>
+              <a:ext uri="{FF2B5EF4-FFF2-40B4-BE49-F238E27FC236}">
+                <a16:creationId xmlns:a16="http://schemas.microsoft.com/office/drawing/2014/main" id="{46F7F170-DA4A-8AE3-E69F-29D08EC0880B}"/>
+              </a:ext>
+            </a:extLst>
+          </p:cNvPr>
+          <p:cNvCxnSpPr>
+            <a:cxnSpLocks/>
+          </p:cNvCxnSpPr>
+          <p:nvPr/>
+        </p:nvCxnSpPr>
+        <p:spPr>
+          <a:xfrm>
+            <a:off x="6514722" y="5104655"/>
+            <a:ext cx="423217" cy="0"/>
+          </a:xfrm>
+          <a:prstGeom prst="straightConnector1">
+            <a:avLst/>
+          </a:prstGeom>
+          <a:ln w="47625">
+            <a:solidFill>
+              <a:srgbClr val="FF0000"/>
+            </a:solidFill>
+            <a:tailEnd type="triangle"/>
+          </a:ln>
+        </p:spPr>
+        <p:style>
+          <a:lnRef idx="2">
+            <a:schemeClr val="dk1"/>
+          </a:lnRef>
+          <a:fillRef idx="0">
+            <a:schemeClr val="dk1"/>
+          </a:fillRef>
+          <a:effectRef idx="1">
+            <a:schemeClr val="dk1"/>
+          </a:effectRef>
+          <a:fontRef idx="minor">
+            <a:schemeClr val="tx1"/>
+          </a:fontRef>
+        </p:style>
+      </p:cxnSp>
+      <p:cxnSp>
+        <p:nvCxnSpPr>
+          <p:cNvPr id="30" name="Straight Arrow Connector 29">
+            <a:extLst>
+              <a:ext uri="{FF2B5EF4-FFF2-40B4-BE49-F238E27FC236}">
+                <a16:creationId xmlns:a16="http://schemas.microsoft.com/office/drawing/2014/main" id="{5A90BBC9-7C69-CFB4-5DF5-41C8AA26D705}"/>
+              </a:ext>
+            </a:extLst>
+          </p:cNvPr>
+          <p:cNvCxnSpPr>
+            <a:cxnSpLocks/>
+          </p:cNvCxnSpPr>
+          <p:nvPr/>
+        </p:nvCxnSpPr>
+        <p:spPr>
+          <a:xfrm>
+            <a:off x="6514722" y="4897964"/>
+            <a:ext cx="423217" cy="0"/>
+          </a:xfrm>
+          <a:prstGeom prst="straightConnector1">
+            <a:avLst/>
+          </a:prstGeom>
+          <a:ln w="47625">
+            <a:solidFill>
+              <a:schemeClr val="accent3">
+                <a:lumMod val="60000"/>
+                <a:lumOff val="40000"/>
+              </a:schemeClr>
+            </a:solidFill>
+            <a:tailEnd type="triangle"/>
+          </a:ln>
+        </p:spPr>
+        <p:style>
+          <a:lnRef idx="2">
+            <a:schemeClr val="dk1"/>
+          </a:lnRef>
+          <a:fillRef idx="0">
+            <a:schemeClr val="dk1"/>
+          </a:fillRef>
+          <a:effectRef idx="1">
+            <a:schemeClr val="dk1"/>
+          </a:effectRef>
+          <a:fontRef idx="minor">
+            <a:schemeClr val="tx1"/>
+          </a:fontRef>
+        </p:style>
+      </p:cxnSp>
+      <p:cxnSp>
+        <p:nvCxnSpPr>
+          <p:cNvPr id="31" name="Straight Arrow Connector 30">
+            <a:extLst>
+              <a:ext uri="{FF2B5EF4-FFF2-40B4-BE49-F238E27FC236}">
+                <a16:creationId xmlns:a16="http://schemas.microsoft.com/office/drawing/2014/main" id="{01D89120-FB9C-58B9-EE1C-C14DE2FA5931}"/>
+              </a:ext>
+            </a:extLst>
+          </p:cNvPr>
+          <p:cNvCxnSpPr>
+            <a:cxnSpLocks/>
+          </p:cNvCxnSpPr>
+          <p:nvPr/>
+        </p:nvCxnSpPr>
+        <p:spPr>
+          <a:xfrm>
+            <a:off x="7263488" y="2401300"/>
+            <a:ext cx="1013126" cy="763458"/>
+          </a:xfrm>
+          <a:prstGeom prst="straightConnector1">
+            <a:avLst/>
+          </a:prstGeom>
+          <a:ln w="47625">
+            <a:solidFill>
+              <a:schemeClr val="accent3">
+                <a:lumMod val="60000"/>
+                <a:lumOff val="40000"/>
+              </a:schemeClr>
+            </a:solidFill>
+            <a:tailEnd type="triangle"/>
+          </a:ln>
+        </p:spPr>
+        <p:style>
+          <a:lnRef idx="2">
+            <a:schemeClr val="dk1"/>
+          </a:lnRef>
+          <a:fillRef idx="0">
+            <a:schemeClr val="dk1"/>
+          </a:fillRef>
+          <a:effectRef idx="1">
+            <a:schemeClr val="dk1"/>
+          </a:effectRef>
+          <a:fontRef idx="minor">
+            <a:schemeClr val="tx1"/>
+          </a:fontRef>
+        </p:style>
+      </p:cxnSp>
+      <p:cxnSp>
+        <p:nvCxnSpPr>
+          <p:cNvPr id="32" name="Straight Arrow Connector 31">
+            <a:extLst>
+              <a:ext uri="{FF2B5EF4-FFF2-40B4-BE49-F238E27FC236}">
+                <a16:creationId xmlns:a16="http://schemas.microsoft.com/office/drawing/2014/main" id="{7F1FF2A4-C87E-AF59-CD0B-0EA071A79662}"/>
+              </a:ext>
+            </a:extLst>
+          </p:cNvPr>
+          <p:cNvCxnSpPr>
+            <a:cxnSpLocks/>
+          </p:cNvCxnSpPr>
+          <p:nvPr/>
+        </p:nvCxnSpPr>
+        <p:spPr>
+          <a:xfrm flipH="1">
+            <a:off x="7664802" y="3230694"/>
+            <a:ext cx="643697" cy="547640"/>
+          </a:xfrm>
+          <a:prstGeom prst="straightConnector1">
+            <a:avLst/>
+          </a:prstGeom>
+          <a:ln w="47625">
+            <a:solidFill>
+              <a:schemeClr val="accent3">
+                <a:lumMod val="60000"/>
+                <a:lumOff val="40000"/>
+              </a:schemeClr>
+            </a:solidFill>
+            <a:tailEnd type="triangle"/>
+          </a:ln>
+        </p:spPr>
+        <p:style>
+          <a:lnRef idx="2">
+            <a:schemeClr val="dk1"/>
+          </a:lnRef>
+          <a:fillRef idx="0">
+            <a:schemeClr val="dk1"/>
+          </a:fillRef>
+          <a:effectRef idx="1">
+            <a:schemeClr val="dk1"/>
+          </a:effectRef>
+          <a:fontRef idx="minor">
+            <a:schemeClr val="tx1"/>
+          </a:fontRef>
+        </p:style>
+      </p:cxnSp>
+      <p:sp>
+        <p:nvSpPr>
+          <p:cNvPr id="33" name="TextBox 32">
+            <a:extLst>
+              <a:ext uri="{FF2B5EF4-FFF2-40B4-BE49-F238E27FC236}">
+                <a16:creationId xmlns:a16="http://schemas.microsoft.com/office/drawing/2014/main" id="{F59A298B-E702-1EA6-13FD-5FB0391B02AE}"/>
+              </a:ext>
+            </a:extLst>
+          </p:cNvPr>
+          <p:cNvSpPr txBox="1"/>
+          <p:nvPr/>
+        </p:nvSpPr>
+        <p:spPr>
+          <a:xfrm>
+            <a:off x="7028508" y="4791461"/>
+            <a:ext cx="1132233" cy="461665"/>
+          </a:xfrm>
+          <a:prstGeom prst="rect">
+            <a:avLst/>
+          </a:prstGeom>
+          <a:noFill/>
+        </p:spPr>
+        <p:txBody>
+          <a:bodyPr wrap="none" rtlCol="0">
+            <a:spAutoFit/>
+          </a:bodyPr>
+          <a:lstStyle/>
+          <a:p>
+            <a:r>
+              <a:rPr lang="en-US" sz="1200" dirty="0"/>
+              <a:t>Low proximity</a:t>
+            </a:r>
+          </a:p>
+          <a:p>
+            <a:r>
+              <a:rPr lang="en-US" sz="1200" dirty="0"/>
+              <a:t>High proximity</a:t>
+            </a:r>
+          </a:p>
+        </p:txBody>
+      </p:sp>
+      <p:cxnSp>
+        <p:nvCxnSpPr>
+          <p:cNvPr id="34" name="Straight Arrow Connector 33">
+            <a:extLst>
+              <a:ext uri="{FF2B5EF4-FFF2-40B4-BE49-F238E27FC236}">
+                <a16:creationId xmlns:a16="http://schemas.microsoft.com/office/drawing/2014/main" id="{683B4E7B-9CAB-A311-5E93-C92524DE03D0}"/>
+              </a:ext>
+            </a:extLst>
+          </p:cNvPr>
+          <p:cNvCxnSpPr>
+            <a:cxnSpLocks/>
+          </p:cNvCxnSpPr>
+          <p:nvPr/>
+        </p:nvCxnSpPr>
+        <p:spPr>
+          <a:xfrm flipV="1">
+            <a:off x="6942611" y="3479902"/>
+            <a:ext cx="327049" cy="1037"/>
+          </a:xfrm>
+          <a:prstGeom prst="straightConnector1">
+            <a:avLst/>
+          </a:prstGeom>
+          <a:ln w="47625">
+            <a:solidFill>
+              <a:srgbClr val="FF0000"/>
+            </a:solidFill>
+            <a:tailEnd type="triangle"/>
+          </a:ln>
+        </p:spPr>
+        <p:style>
+          <a:lnRef idx="2">
+            <a:schemeClr val="dk1"/>
+          </a:lnRef>
+          <a:fillRef idx="0">
+            <a:schemeClr val="dk1"/>
+          </a:fillRef>
+          <a:effectRef idx="1">
+            <a:schemeClr val="dk1"/>
+          </a:effectRef>
+          <a:fontRef idx="minor">
+            <a:schemeClr val="tx1"/>
+          </a:fontRef>
+        </p:style>
+      </p:cxnSp>
+      <p:cxnSp>
+        <p:nvCxnSpPr>
+          <p:cNvPr id="35" name="Straight Arrow Connector 34">
+            <a:extLst>
+              <a:ext uri="{FF2B5EF4-FFF2-40B4-BE49-F238E27FC236}">
+                <a16:creationId xmlns:a16="http://schemas.microsoft.com/office/drawing/2014/main" id="{CC3C2199-BF4A-9FAA-226A-4C4113BFFB5A}"/>
+              </a:ext>
+            </a:extLst>
+          </p:cNvPr>
+          <p:cNvCxnSpPr>
+            <a:cxnSpLocks/>
+          </p:cNvCxnSpPr>
+          <p:nvPr/>
+        </p:nvCxnSpPr>
+        <p:spPr>
+          <a:xfrm flipV="1">
+            <a:off x="872886" y="4020924"/>
+            <a:ext cx="563646" cy="78043"/>
+          </a:xfrm>
+          <a:prstGeom prst="straightConnector1">
+            <a:avLst/>
+          </a:prstGeom>
+          <a:ln w="47625">
+            <a:solidFill>
+              <a:schemeClr val="accent3">
+                <a:lumMod val="60000"/>
+                <a:lumOff val="40000"/>
+              </a:schemeClr>
+            </a:solidFill>
+            <a:tailEnd type="triangle"/>
+          </a:ln>
+        </p:spPr>
+        <p:style>
+          <a:lnRef idx="2">
+            <a:schemeClr val="dk1"/>
+          </a:lnRef>
+          <a:fillRef idx="0">
+            <a:schemeClr val="dk1"/>
+          </a:fillRef>
+          <a:effectRef idx="1">
+            <a:schemeClr val="dk1"/>
+          </a:effectRef>
+          <a:fontRef idx="minor">
+            <a:schemeClr val="tx1"/>
+          </a:fontRef>
+        </p:style>
+      </p:cxnSp>
+      <p:cxnSp>
+        <p:nvCxnSpPr>
+          <p:cNvPr id="36" name="Straight Arrow Connector 35">
+            <a:extLst>
+              <a:ext uri="{FF2B5EF4-FFF2-40B4-BE49-F238E27FC236}">
+                <a16:creationId xmlns:a16="http://schemas.microsoft.com/office/drawing/2014/main" id="{244961D2-58AE-97CC-CC77-781774BD4587}"/>
+              </a:ext>
+            </a:extLst>
+          </p:cNvPr>
+          <p:cNvCxnSpPr>
+            <a:cxnSpLocks/>
+          </p:cNvCxnSpPr>
+          <p:nvPr/>
+        </p:nvCxnSpPr>
+        <p:spPr>
+          <a:xfrm>
+            <a:off x="1562449" y="4032050"/>
+            <a:ext cx="617203" cy="22499"/>
+          </a:xfrm>
+          <a:prstGeom prst="straightConnector1">
+            <a:avLst/>
+          </a:prstGeom>
+          <a:ln w="47625">
+            <a:solidFill>
+              <a:schemeClr val="accent3">
+                <a:lumMod val="60000"/>
+                <a:lumOff val="40000"/>
+              </a:schemeClr>
+            </a:solidFill>
+            <a:tailEnd type="triangle"/>
+          </a:ln>
+        </p:spPr>
+        <p:style>
+          <a:lnRef idx="2">
+            <a:schemeClr val="dk1"/>
+          </a:lnRef>
+          <a:fillRef idx="0">
+            <a:schemeClr val="dk1"/>
+          </a:fillRef>
+          <a:effectRef idx="1">
+            <a:schemeClr val="dk1"/>
+          </a:effectRef>
+          <a:fontRef idx="minor">
+            <a:schemeClr val="tx1"/>
+          </a:fontRef>
+        </p:style>
+      </p:cxnSp>
+      <p:cxnSp>
+        <p:nvCxnSpPr>
+          <p:cNvPr id="37" name="Straight Arrow Connector 36">
+            <a:extLst>
+              <a:ext uri="{FF2B5EF4-FFF2-40B4-BE49-F238E27FC236}">
+                <a16:creationId xmlns:a16="http://schemas.microsoft.com/office/drawing/2014/main" id="{74683CE8-E70A-47D2-94ED-545734B4C239}"/>
+              </a:ext>
+            </a:extLst>
+          </p:cNvPr>
+          <p:cNvCxnSpPr>
+            <a:cxnSpLocks/>
+          </p:cNvCxnSpPr>
+          <p:nvPr/>
+        </p:nvCxnSpPr>
+        <p:spPr>
+          <a:xfrm>
+            <a:off x="1118131" y="5090776"/>
+            <a:ext cx="368792" cy="397"/>
+          </a:xfrm>
+          <a:prstGeom prst="straightConnector1">
+            <a:avLst/>
+          </a:prstGeom>
+          <a:ln w="47625">
+            <a:solidFill>
+              <a:srgbClr val="FF0000"/>
+            </a:solidFill>
+            <a:tailEnd type="triangle"/>
+          </a:ln>
+        </p:spPr>
+        <p:style>
+          <a:lnRef idx="2">
+            <a:schemeClr val="dk1"/>
+          </a:lnRef>
+          <a:fillRef idx="0">
+            <a:schemeClr val="dk1"/>
+          </a:fillRef>
+          <a:effectRef idx="1">
+            <a:schemeClr val="dk1"/>
+          </a:effectRef>
+          <a:fontRef idx="minor">
+            <a:schemeClr val="tx1"/>
+          </a:fontRef>
+        </p:style>
+      </p:cxnSp>
+      <p:cxnSp>
+        <p:nvCxnSpPr>
+          <p:cNvPr id="38" name="Straight Arrow Connector 37">
+            <a:extLst>
+              <a:ext uri="{FF2B5EF4-FFF2-40B4-BE49-F238E27FC236}">
+                <a16:creationId xmlns:a16="http://schemas.microsoft.com/office/drawing/2014/main" id="{BADD7127-F1AC-7EDE-C089-FD1C461C2503}"/>
+              </a:ext>
+            </a:extLst>
+          </p:cNvPr>
+          <p:cNvCxnSpPr>
+            <a:cxnSpLocks/>
+          </p:cNvCxnSpPr>
+          <p:nvPr/>
+        </p:nvCxnSpPr>
+        <p:spPr>
+          <a:xfrm flipH="1">
+            <a:off x="399180" y="5143038"/>
+            <a:ext cx="903347" cy="0"/>
+          </a:xfrm>
+          <a:prstGeom prst="straightConnector1">
+            <a:avLst/>
+          </a:prstGeom>
+          <a:ln w="47625">
+            <a:solidFill>
+              <a:srgbClr val="FF0000"/>
+            </a:solidFill>
+            <a:tailEnd type="triangle"/>
+          </a:ln>
+        </p:spPr>
+        <p:style>
+          <a:lnRef idx="2">
+            <a:schemeClr val="dk1"/>
+          </a:lnRef>
+          <a:fillRef idx="0">
+            <a:schemeClr val="dk1"/>
+          </a:fillRef>
+          <a:effectRef idx="1">
+            <a:schemeClr val="dk1"/>
+          </a:effectRef>
+          <a:fontRef idx="minor">
+            <a:schemeClr val="tx1"/>
+          </a:fontRef>
+        </p:style>
+      </p:cxnSp>
+      <p:cxnSp>
+        <p:nvCxnSpPr>
+          <p:cNvPr id="39" name="Straight Arrow Connector 38">
+            <a:extLst>
+              <a:ext uri="{FF2B5EF4-FFF2-40B4-BE49-F238E27FC236}">
+                <a16:creationId xmlns:a16="http://schemas.microsoft.com/office/drawing/2014/main" id="{1DF96B9E-FDEC-C1C1-FF78-05B662490006}"/>
+              </a:ext>
+            </a:extLst>
+          </p:cNvPr>
+          <p:cNvCxnSpPr>
+            <a:cxnSpLocks/>
+          </p:cNvCxnSpPr>
+          <p:nvPr/>
+        </p:nvCxnSpPr>
+        <p:spPr>
+          <a:xfrm>
+            <a:off x="721991" y="6531285"/>
+            <a:ext cx="423217" cy="0"/>
+          </a:xfrm>
+          <a:prstGeom prst="straightConnector1">
+            <a:avLst/>
+          </a:prstGeom>
+          <a:ln w="47625">
+            <a:solidFill>
+              <a:schemeClr val="accent3">
+                <a:lumMod val="60000"/>
+                <a:lumOff val="40000"/>
+              </a:schemeClr>
+            </a:solidFill>
+            <a:tailEnd type="triangle"/>
+          </a:ln>
+        </p:spPr>
+        <p:style>
+          <a:lnRef idx="2">
+            <a:schemeClr val="dk1"/>
+          </a:lnRef>
+          <a:fillRef idx="0">
+            <a:schemeClr val="dk1"/>
+          </a:fillRef>
+          <a:effectRef idx="1">
+            <a:schemeClr val="dk1"/>
+          </a:effectRef>
+          <a:fontRef idx="minor">
+            <a:schemeClr val="tx1"/>
+          </a:fontRef>
+        </p:style>
+      </p:cxnSp>
+      <p:cxnSp>
+        <p:nvCxnSpPr>
+          <p:cNvPr id="40" name="Straight Arrow Connector 39">
+            <a:extLst>
+              <a:ext uri="{FF2B5EF4-FFF2-40B4-BE49-F238E27FC236}">
+                <a16:creationId xmlns:a16="http://schemas.microsoft.com/office/drawing/2014/main" id="{2C4DC2FD-A804-703F-5388-70A642E12F58}"/>
+              </a:ext>
+            </a:extLst>
+          </p:cNvPr>
+          <p:cNvCxnSpPr>
+            <a:cxnSpLocks/>
+          </p:cNvCxnSpPr>
+          <p:nvPr/>
+        </p:nvCxnSpPr>
+        <p:spPr>
+          <a:xfrm>
+            <a:off x="721990" y="6713773"/>
+            <a:ext cx="423217" cy="0"/>
+          </a:xfrm>
+          <a:prstGeom prst="straightConnector1">
+            <a:avLst/>
+          </a:prstGeom>
+          <a:ln w="47625">
+            <a:solidFill>
+              <a:srgbClr val="FF0000"/>
+            </a:solidFill>
+            <a:tailEnd type="triangle"/>
+          </a:ln>
+        </p:spPr>
+        <p:style>
+          <a:lnRef idx="2">
+            <a:schemeClr val="dk1"/>
+          </a:lnRef>
+          <a:fillRef idx="0">
+            <a:schemeClr val="dk1"/>
+          </a:fillRef>
+          <a:effectRef idx="1">
+            <a:schemeClr val="dk1"/>
+          </a:effectRef>
+          <a:fontRef idx="minor">
+            <a:schemeClr val="tx1"/>
+          </a:fontRef>
+        </p:style>
+      </p:cxnSp>
+      <p:sp>
+        <p:nvSpPr>
+          <p:cNvPr id="41" name="TextBox 40">
+            <a:extLst>
+              <a:ext uri="{FF2B5EF4-FFF2-40B4-BE49-F238E27FC236}">
+                <a16:creationId xmlns:a16="http://schemas.microsoft.com/office/drawing/2014/main" id="{7D49D6B3-6A2C-CB8B-B33F-45BC50AB2B1F}"/>
+              </a:ext>
+            </a:extLst>
+          </p:cNvPr>
+          <p:cNvSpPr txBox="1"/>
+          <p:nvPr/>
+        </p:nvSpPr>
+        <p:spPr>
+          <a:xfrm>
+            <a:off x="1262093" y="6406583"/>
+            <a:ext cx="917559" cy="461665"/>
+          </a:xfrm>
+          <a:prstGeom prst="rect">
+            <a:avLst/>
+          </a:prstGeom>
+          <a:noFill/>
+        </p:spPr>
+        <p:txBody>
+          <a:bodyPr wrap="none" rtlCol="0">
+            <a:spAutoFit/>
+          </a:bodyPr>
+          <a:lstStyle/>
+          <a:p>
+            <a:r>
+              <a:rPr lang="en-US" sz="1200" dirty="0"/>
+              <a:t>Forwards</a:t>
+            </a:r>
+          </a:p>
+          <a:p>
+            <a:r>
+              <a:rPr lang="en-US" sz="1200" dirty="0"/>
+              <a:t>Backwards</a:t>
+            </a:r>
+          </a:p>
+        </p:txBody>
+      </p:sp>
+      <p:sp>
+        <p:nvSpPr>
+          <p:cNvPr id="43" name="TextBox 42">
+            <a:extLst>
+              <a:ext uri="{FF2B5EF4-FFF2-40B4-BE49-F238E27FC236}">
+                <a16:creationId xmlns:a16="http://schemas.microsoft.com/office/drawing/2014/main" id="{E12118FF-510C-50BB-CA8C-03F8E0773659}"/>
+              </a:ext>
+            </a:extLst>
+          </p:cNvPr>
+          <p:cNvSpPr txBox="1"/>
+          <p:nvPr/>
+        </p:nvSpPr>
+        <p:spPr>
+          <a:xfrm>
+            <a:off x="2978818" y="3502727"/>
+            <a:ext cx="2835349" cy="369332"/>
+          </a:xfrm>
+          <a:prstGeom prst="rect">
+            <a:avLst/>
+          </a:prstGeom>
+          <a:noFill/>
+        </p:spPr>
+        <p:txBody>
+          <a:bodyPr wrap="square" rtlCol="0">
+            <a:spAutoFit/>
+          </a:bodyPr>
+          <a:lstStyle/>
+          <a:p>
+            <a:pPr algn="ctr"/>
+            <a:r>
+              <a:rPr lang="en-US" dirty="0"/>
+              <a:t>Absolute direction (</a:t>
+            </a:r>
+            <a:r>
+              <a:rPr lang="el-GR" dirty="0"/>
+              <a:t>ϑ</a:t>
+            </a:r>
+            <a:r>
+              <a:rPr lang="en-GB" dirty="0"/>
+              <a:t>)</a:t>
+            </a:r>
+            <a:endParaRPr lang="en-US" dirty="0"/>
+          </a:p>
+        </p:txBody>
+      </p:sp>
+      <p:cxnSp>
+        <p:nvCxnSpPr>
+          <p:cNvPr id="44" name="Straight Arrow Connector 43">
+            <a:extLst>
+              <a:ext uri="{FF2B5EF4-FFF2-40B4-BE49-F238E27FC236}">
+                <a16:creationId xmlns:a16="http://schemas.microsoft.com/office/drawing/2014/main" id="{0C5FD68D-C9B3-0174-88B9-335CEF44C15C}"/>
+              </a:ext>
+            </a:extLst>
+          </p:cNvPr>
+          <p:cNvCxnSpPr>
+            <a:cxnSpLocks/>
+          </p:cNvCxnSpPr>
+          <p:nvPr/>
+        </p:nvCxnSpPr>
+        <p:spPr>
+          <a:xfrm>
+            <a:off x="3062566" y="6530808"/>
+            <a:ext cx="423217" cy="0"/>
+          </a:xfrm>
+          <a:prstGeom prst="straightConnector1">
+            <a:avLst/>
+          </a:prstGeom>
+          <a:ln w="47625">
+            <a:solidFill>
+              <a:schemeClr val="accent3">
+                <a:lumMod val="60000"/>
+                <a:lumOff val="40000"/>
+              </a:schemeClr>
+            </a:solidFill>
+            <a:tailEnd type="triangle"/>
+          </a:ln>
+        </p:spPr>
+        <p:style>
+          <a:lnRef idx="2">
+            <a:schemeClr val="dk1"/>
+          </a:lnRef>
+          <a:fillRef idx="0">
+            <a:schemeClr val="dk1"/>
+          </a:fillRef>
+          <a:effectRef idx="1">
+            <a:schemeClr val="dk1"/>
+          </a:effectRef>
+          <a:fontRef idx="minor">
+            <a:schemeClr val="tx1"/>
+          </a:fontRef>
+        </p:style>
+      </p:cxnSp>
+      <p:cxnSp>
+        <p:nvCxnSpPr>
+          <p:cNvPr id="45" name="Straight Arrow Connector 44">
+            <a:extLst>
+              <a:ext uri="{FF2B5EF4-FFF2-40B4-BE49-F238E27FC236}">
+                <a16:creationId xmlns:a16="http://schemas.microsoft.com/office/drawing/2014/main" id="{A02A8CD8-0F04-245E-D318-9A18ED6E8FB3}"/>
+              </a:ext>
+            </a:extLst>
+          </p:cNvPr>
+          <p:cNvCxnSpPr>
+            <a:cxnSpLocks/>
+          </p:cNvCxnSpPr>
+          <p:nvPr/>
+        </p:nvCxnSpPr>
+        <p:spPr>
+          <a:xfrm>
+            <a:off x="3062566" y="6724403"/>
+            <a:ext cx="423217" cy="0"/>
+          </a:xfrm>
+          <a:prstGeom prst="straightConnector1">
+            <a:avLst/>
+          </a:prstGeom>
+          <a:ln w="47625">
+            <a:solidFill>
+              <a:srgbClr val="FF0000"/>
+            </a:solidFill>
+            <a:tailEnd type="triangle"/>
+          </a:ln>
+        </p:spPr>
+        <p:style>
+          <a:lnRef idx="2">
+            <a:schemeClr val="dk1"/>
+          </a:lnRef>
+          <a:fillRef idx="0">
+            <a:schemeClr val="dk1"/>
+          </a:fillRef>
+          <a:effectRef idx="1">
+            <a:schemeClr val="dk1"/>
+          </a:effectRef>
+          <a:fontRef idx="minor">
+            <a:schemeClr val="tx1"/>
+          </a:fontRef>
+        </p:style>
+      </p:cxnSp>
+      <p:sp>
+        <p:nvSpPr>
+          <p:cNvPr id="46" name="TextBox 45">
+            <a:extLst>
+              <a:ext uri="{FF2B5EF4-FFF2-40B4-BE49-F238E27FC236}">
+                <a16:creationId xmlns:a16="http://schemas.microsoft.com/office/drawing/2014/main" id="{33B05AE1-0703-DE65-9529-867F664CAD25}"/>
+              </a:ext>
+            </a:extLst>
+          </p:cNvPr>
+          <p:cNvSpPr txBox="1"/>
+          <p:nvPr/>
+        </p:nvSpPr>
+        <p:spPr>
+          <a:xfrm>
+            <a:off x="3469950" y="6413249"/>
+            <a:ext cx="2513701" cy="461665"/>
+          </a:xfrm>
+          <a:prstGeom prst="rect">
+            <a:avLst/>
+          </a:prstGeom>
+          <a:noFill/>
+        </p:spPr>
+        <p:txBody>
+          <a:bodyPr wrap="none" rtlCol="0">
+            <a:spAutoFit/>
+          </a:bodyPr>
+          <a:lstStyle/>
+          <a:p>
+            <a:r>
+              <a:rPr lang="en-US" sz="1200" dirty="0"/>
+              <a:t>Preference for horizontal directions</a:t>
+            </a:r>
+          </a:p>
+          <a:p>
+            <a:r>
+              <a:rPr lang="en-US" sz="1200" dirty="0"/>
+              <a:t>Preference for vertical directions</a:t>
+            </a:r>
+          </a:p>
+        </p:txBody>
+      </p:sp>
+      <p:cxnSp>
+        <p:nvCxnSpPr>
+          <p:cNvPr id="47" name="Straight Arrow Connector 46">
+            <a:extLst>
+              <a:ext uri="{FF2B5EF4-FFF2-40B4-BE49-F238E27FC236}">
+                <a16:creationId xmlns:a16="http://schemas.microsoft.com/office/drawing/2014/main" id="{2CD68508-4C51-A989-6372-7168C8BB9B55}"/>
+              </a:ext>
+            </a:extLst>
+          </p:cNvPr>
+          <p:cNvCxnSpPr>
+            <a:cxnSpLocks/>
+          </p:cNvCxnSpPr>
+          <p:nvPr/>
+        </p:nvCxnSpPr>
+        <p:spPr>
+          <a:xfrm>
+            <a:off x="3344118" y="4032050"/>
+            <a:ext cx="247971" cy="56226"/>
+          </a:xfrm>
+          <a:prstGeom prst="straightConnector1">
+            <a:avLst/>
+          </a:prstGeom>
+          <a:ln w="47625">
+            <a:solidFill>
+              <a:schemeClr val="accent3">
+                <a:lumMod val="60000"/>
+                <a:lumOff val="40000"/>
+              </a:schemeClr>
+            </a:solidFill>
+            <a:tailEnd type="triangle"/>
+          </a:ln>
+        </p:spPr>
+        <p:style>
+          <a:lnRef idx="2">
+            <a:schemeClr val="dk1"/>
+          </a:lnRef>
+          <a:fillRef idx="0">
+            <a:schemeClr val="dk1"/>
+          </a:fillRef>
+          <a:effectRef idx="1">
+            <a:schemeClr val="dk1"/>
+          </a:effectRef>
+          <a:fontRef idx="minor">
+            <a:schemeClr val="tx1"/>
+          </a:fontRef>
+        </p:style>
+      </p:cxnSp>
+      <p:cxnSp>
+        <p:nvCxnSpPr>
+          <p:cNvPr id="48" name="Straight Arrow Connector 47">
+            <a:extLst>
+              <a:ext uri="{FF2B5EF4-FFF2-40B4-BE49-F238E27FC236}">
+                <a16:creationId xmlns:a16="http://schemas.microsoft.com/office/drawing/2014/main" id="{61559225-1248-ACE8-439B-9DCF9AC84E7C}"/>
+              </a:ext>
+            </a:extLst>
+          </p:cNvPr>
+          <p:cNvCxnSpPr>
+            <a:cxnSpLocks/>
+          </p:cNvCxnSpPr>
+          <p:nvPr/>
+        </p:nvCxnSpPr>
+        <p:spPr>
+          <a:xfrm>
+            <a:off x="3767536" y="4068959"/>
+            <a:ext cx="573156" cy="0"/>
+          </a:xfrm>
+          <a:prstGeom prst="straightConnector1">
+            <a:avLst/>
+          </a:prstGeom>
+          <a:ln w="47625">
+            <a:solidFill>
+              <a:schemeClr val="accent3">
+                <a:lumMod val="60000"/>
+                <a:lumOff val="40000"/>
+              </a:schemeClr>
+            </a:solidFill>
+            <a:tailEnd type="triangle"/>
+          </a:ln>
+        </p:spPr>
+        <p:style>
+          <a:lnRef idx="2">
+            <a:schemeClr val="dk1"/>
+          </a:lnRef>
+          <a:fillRef idx="0">
+            <a:schemeClr val="dk1"/>
+          </a:fillRef>
+          <a:effectRef idx="1">
+            <a:schemeClr val="dk1"/>
+          </a:effectRef>
+          <a:fontRef idx="minor">
+            <a:schemeClr val="tx1"/>
+          </a:fontRef>
+        </p:style>
+      </p:cxnSp>
+      <p:cxnSp>
+        <p:nvCxnSpPr>
+          <p:cNvPr id="49" name="Straight Arrow Connector 48">
+            <a:extLst>
+              <a:ext uri="{FF2B5EF4-FFF2-40B4-BE49-F238E27FC236}">
+                <a16:creationId xmlns:a16="http://schemas.microsoft.com/office/drawing/2014/main" id="{AA4FC850-A709-948C-E96C-4F9E97660678}"/>
+              </a:ext>
+            </a:extLst>
+          </p:cNvPr>
+          <p:cNvCxnSpPr>
+            <a:cxnSpLocks/>
+          </p:cNvCxnSpPr>
+          <p:nvPr/>
+        </p:nvCxnSpPr>
+        <p:spPr>
+          <a:xfrm>
+            <a:off x="4496871" y="4066585"/>
+            <a:ext cx="562628" cy="0"/>
+          </a:xfrm>
+          <a:prstGeom prst="straightConnector1">
+            <a:avLst/>
+          </a:prstGeom>
+          <a:ln w="47625">
+            <a:solidFill>
+              <a:schemeClr val="accent3">
+                <a:lumMod val="60000"/>
+                <a:lumOff val="40000"/>
+              </a:schemeClr>
+            </a:solidFill>
+            <a:tailEnd type="triangle"/>
+          </a:ln>
+        </p:spPr>
+        <p:style>
+          <a:lnRef idx="2">
+            <a:schemeClr val="dk1"/>
+          </a:lnRef>
+          <a:fillRef idx="0">
+            <a:schemeClr val="dk1"/>
+          </a:fillRef>
+          <a:effectRef idx="1">
+            <a:schemeClr val="dk1"/>
+          </a:effectRef>
+          <a:fontRef idx="minor">
+            <a:schemeClr val="tx1"/>
+          </a:fontRef>
+        </p:style>
+      </p:cxnSp>
+      <p:cxnSp>
+        <p:nvCxnSpPr>
+          <p:cNvPr id="50" name="Straight Arrow Connector 49">
+            <a:extLst>
+              <a:ext uri="{FF2B5EF4-FFF2-40B4-BE49-F238E27FC236}">
+                <a16:creationId xmlns:a16="http://schemas.microsoft.com/office/drawing/2014/main" id="{EA313F16-2862-EB82-E8BA-566545F5EC94}"/>
+              </a:ext>
+            </a:extLst>
+          </p:cNvPr>
+          <p:cNvCxnSpPr>
+            <a:cxnSpLocks/>
+          </p:cNvCxnSpPr>
+          <p:nvPr/>
+        </p:nvCxnSpPr>
+        <p:spPr>
+          <a:xfrm>
+            <a:off x="4409965" y="4784919"/>
+            <a:ext cx="0" cy="301264"/>
+          </a:xfrm>
+          <a:prstGeom prst="straightConnector1">
+            <a:avLst/>
+          </a:prstGeom>
+          <a:ln w="47625">
+            <a:solidFill>
+              <a:srgbClr val="FF0000"/>
+            </a:solidFill>
+            <a:tailEnd type="triangle"/>
+          </a:ln>
+        </p:spPr>
+        <p:style>
+          <a:lnRef idx="2">
+            <a:schemeClr val="dk1"/>
+          </a:lnRef>
+          <a:fillRef idx="0">
+            <a:schemeClr val="dk1"/>
+          </a:fillRef>
+          <a:effectRef idx="1">
+            <a:schemeClr val="dk1"/>
+          </a:effectRef>
+          <a:fontRef idx="minor">
+            <a:schemeClr val="tx1"/>
+          </a:fontRef>
+        </p:style>
+      </p:cxnSp>
+      <p:cxnSp>
+        <p:nvCxnSpPr>
+          <p:cNvPr id="51" name="Straight Arrow Connector 50">
+            <a:extLst>
+              <a:ext uri="{FF2B5EF4-FFF2-40B4-BE49-F238E27FC236}">
+                <a16:creationId xmlns:a16="http://schemas.microsoft.com/office/drawing/2014/main" id="{545E3301-C4AC-7784-A12B-E06FC9348F72}"/>
+              </a:ext>
+            </a:extLst>
+          </p:cNvPr>
+          <p:cNvCxnSpPr>
+            <a:cxnSpLocks/>
+          </p:cNvCxnSpPr>
+          <p:nvPr/>
+        </p:nvCxnSpPr>
+        <p:spPr>
+          <a:xfrm>
+            <a:off x="4396491" y="5143038"/>
+            <a:ext cx="0" cy="334126"/>
+          </a:xfrm>
+          <a:prstGeom prst="straightConnector1">
+            <a:avLst/>
+          </a:prstGeom>
+          <a:ln w="47625">
+            <a:solidFill>
+              <a:srgbClr val="FF0000"/>
+            </a:solidFill>
+            <a:tailEnd type="triangle"/>
+          </a:ln>
+        </p:spPr>
+        <p:style>
+          <a:lnRef idx="2">
+            <a:schemeClr val="dk1"/>
+          </a:lnRef>
+          <a:fillRef idx="0">
+            <a:schemeClr val="dk1"/>
+          </a:fillRef>
+          <a:effectRef idx="1">
+            <a:schemeClr val="dk1"/>
+          </a:effectRef>
+          <a:fontRef idx="minor">
+            <a:schemeClr val="tx1"/>
+          </a:fontRef>
+        </p:style>
+      </p:cxnSp>
+      <p:cxnSp>
+        <p:nvCxnSpPr>
+          <p:cNvPr id="52" name="Straight Arrow Connector 51">
+            <a:extLst>
+              <a:ext uri="{FF2B5EF4-FFF2-40B4-BE49-F238E27FC236}">
+                <a16:creationId xmlns:a16="http://schemas.microsoft.com/office/drawing/2014/main" id="{CDAD3476-6F69-FAED-5D2A-09E3BDDF2202}"/>
+              </a:ext>
+            </a:extLst>
+          </p:cNvPr>
+          <p:cNvCxnSpPr>
+            <a:cxnSpLocks/>
+          </p:cNvCxnSpPr>
+          <p:nvPr/>
+        </p:nvCxnSpPr>
+        <p:spPr>
+          <a:xfrm flipH="1">
+            <a:off x="4340692" y="5595458"/>
+            <a:ext cx="9999" cy="288106"/>
+          </a:xfrm>
+          <a:prstGeom prst="straightConnector1">
+            <a:avLst/>
+          </a:prstGeom>
+          <a:ln w="47625">
+            <a:solidFill>
+              <a:srgbClr val="FF0000"/>
+            </a:solidFill>
+            <a:tailEnd type="triangle"/>
+          </a:ln>
+        </p:spPr>
+        <p:style>
+          <a:lnRef idx="2">
+            <a:schemeClr val="dk1"/>
+          </a:lnRef>
+          <a:fillRef idx="0">
+            <a:schemeClr val="dk1"/>
+          </a:fillRef>
+          <a:effectRef idx="1">
+            <a:schemeClr val="dk1"/>
+          </a:effectRef>
+          <a:fontRef idx="minor">
+            <a:schemeClr val="tx1"/>
+          </a:fontRef>
+        </p:style>
+      </p:cxnSp>
+    </p:spTree>
+    <p:extLst>
+      <p:ext uri="{BB962C8B-B14F-4D97-AF65-F5344CB8AC3E}">
+        <p14:creationId xmlns:p14="http://schemas.microsoft.com/office/powerpoint/2010/main" val="2962922536"/>
+      </p:ext>
+    </p:extLst>
+  </p:cSld>
+  <p:clrMapOvr>
+    <a:masterClrMapping/>
+  </p:clrMapOvr>
+</p:sld>
+</file>
+
 <file path=ppt/theme/theme1.xml><?xml version="1.0" encoding="utf-8"?>
 <a:theme xmlns:a="http://schemas.openxmlformats.org/drawingml/2006/main" name="Office Theme">
   <a:themeElements>
@@ -5835,4 +8435,319 @@
     </a:ext>
   </a:extLst>
 </a:theme>
+</file>
+
+<file path=ppt/theme/theme2.xml><?xml version="1.0" encoding="utf-8"?>
+<a:theme xmlns:a="http://schemas.openxmlformats.org/drawingml/2006/main" name="Office Theme">
+  <a:themeElements>
+    <a:clrScheme name="Office">
+      <a:dk1>
+        <a:sysClr val="windowText" lastClr="000000"/>
+      </a:dk1>
+      <a:lt1>
+        <a:sysClr val="window" lastClr="FFFFFF"/>
+      </a:lt1>
+      <a:dk2>
+        <a:srgbClr val="0E2841"/>
+      </a:dk2>
+      <a:lt2>
+        <a:srgbClr val="E8E8E8"/>
+      </a:lt2>
+      <a:accent1>
+        <a:srgbClr val="156082"/>
+      </a:accent1>
+      <a:accent2>
+        <a:srgbClr val="E97132"/>
+      </a:accent2>
+      <a:accent3>
+        <a:srgbClr val="196B24"/>
+      </a:accent3>
+      <a:accent4>
+        <a:srgbClr val="0F9ED5"/>
+      </a:accent4>
+      <a:accent5>
+        <a:srgbClr val="A02B93"/>
+      </a:accent5>
+      <a:accent6>
+        <a:srgbClr val="4EA72E"/>
+      </a:accent6>
+      <a:hlink>
+        <a:srgbClr val="467886"/>
+      </a:hlink>
+      <a:folHlink>
+        <a:srgbClr val="96607D"/>
+      </a:folHlink>
+    </a:clrScheme>
+    <a:fontScheme name="Office">
+      <a:majorFont>
+        <a:latin typeface="Aptos Display" panose="02110004020202020204"/>
+        <a:ea typeface=""/>
+        <a:cs typeface=""/>
+        <a:font script="Jpan" typeface="游ゴシック Light"/>
+        <a:font script="Hang" typeface="맑은 고딕"/>
+        <a:font script="Hans" typeface="等线 Light"/>
+        <a:font script="Hant" typeface="新細明體"/>
+        <a:font script="Arab" typeface="Times New Roman"/>
+        <a:font script="Hebr" typeface="Times New Roman"/>
+        <a:font script="Thai" typeface="Angsana New"/>
+        <a:font script="Ethi" typeface="Nyala"/>
+        <a:font script="Beng" typeface="Vrinda"/>
+        <a:font script="Gujr" typeface="Shruti"/>
+        <a:font script="Khmr" typeface="MoolBoran"/>
+        <a:font script="Knda" typeface="Tunga"/>
+        <a:font script="Guru" typeface="Raavi"/>
+        <a:font script="Cans" typeface="Euphemia"/>
+        <a:font script="Cher" typeface="Plantagenet Cherokee"/>
+        <a:font script="Yiii" typeface="Microsoft Yi Baiti"/>
+        <a:font script="Tibt" typeface="Microsoft Himalaya"/>
+        <a:font script="Thaa" typeface="MV Boli"/>
+        <a:font script="Deva" typeface="Mangal"/>
+        <a:font script="Telu" typeface="Gautami"/>
+        <a:font script="Taml" typeface="Latha"/>
+        <a:font script="Syrc" typeface="Estrangelo Edessa"/>
+        <a:font script="Orya" typeface="Kalinga"/>
+        <a:font script="Mlym" typeface="Kartika"/>
+        <a:font script="Laoo" typeface="DokChampa"/>
+        <a:font script="Sinh" typeface="Iskoola Pota"/>
+        <a:font script="Mong" typeface="Mongolian Baiti"/>
+        <a:font script="Viet" typeface="Times New Roman"/>
+        <a:font script="Uigh" typeface="Microsoft Uighur"/>
+        <a:font script="Geor" typeface="Sylfaen"/>
+        <a:font script="Armn" typeface="Arial"/>
+        <a:font script="Bugi" typeface="Leelawadee UI"/>
+        <a:font script="Bopo" typeface="Microsoft JhengHei"/>
+        <a:font script="Java" typeface="Javanese Text"/>
+        <a:font script="Lisu" typeface="Segoe UI"/>
+        <a:font script="Mymr" typeface="Myanmar Text"/>
+        <a:font script="Nkoo" typeface="Ebrima"/>
+        <a:font script="Olck" typeface="Nirmala UI"/>
+        <a:font script="Osma" typeface="Ebrima"/>
+        <a:font script="Phag" typeface="Phagspa"/>
+        <a:font script="Syrn" typeface="Estrangelo Edessa"/>
+        <a:font script="Syrj" typeface="Estrangelo Edessa"/>
+        <a:font script="Syre" typeface="Estrangelo Edessa"/>
+        <a:font script="Sora" typeface="Nirmala UI"/>
+        <a:font script="Tale" typeface="Microsoft Tai Le"/>
+        <a:font script="Talu" typeface="Microsoft New Tai Lue"/>
+        <a:font script="Tfng" typeface="Ebrima"/>
+      </a:majorFont>
+      <a:minorFont>
+        <a:latin typeface="Aptos" panose="02110004020202020204"/>
+        <a:ea typeface=""/>
+        <a:cs typeface=""/>
+        <a:font script="Jpan" typeface="游ゴシック"/>
+        <a:font script="Hang" typeface="맑은 고딕"/>
+        <a:font script="Hans" typeface="等线"/>
+        <a:font script="Hant" typeface="新細明體"/>
+        <a:font script="Arab" typeface="Arial"/>
+        <a:font script="Hebr" typeface="Arial"/>
+        <a:font script="Thai" typeface="Cordia New"/>
+        <a:font script="Ethi" typeface="Nyala"/>
+        <a:font script="Beng" typeface="Vrinda"/>
+        <a:font script="Gujr" typeface="Shruti"/>
+        <a:font script="Khmr" typeface="DaunPenh"/>
+        <a:font script="Knda" typeface="Tunga"/>
+        <a:font script="Guru" typeface="Raavi"/>
+        <a:font script="Cans" typeface="Euphemia"/>
+        <a:font script="Cher" typeface="Plantagenet Cherokee"/>
+        <a:font script="Yiii" typeface="Microsoft Yi Baiti"/>
+        <a:font script="Tibt" typeface="Microsoft Himalaya"/>
+        <a:font script="Thaa" typeface="MV Boli"/>
+        <a:font script="Deva" typeface="Mangal"/>
+        <a:font script="Telu" typeface="Gautami"/>
+        <a:font script="Taml" typeface="Latha"/>
+        <a:font script="Syrc" typeface="Estrangelo Edessa"/>
+        <a:font script="Orya" typeface="Kalinga"/>
+        <a:font script="Mlym" typeface="Kartika"/>
+        <a:font script="Laoo" typeface="DokChampa"/>
+        <a:font script="Sinh" typeface="Iskoola Pota"/>
+        <a:font script="Mong" typeface="Mongolian Baiti"/>
+        <a:font script="Viet" typeface="Arial"/>
+        <a:font script="Uigh" typeface="Microsoft Uighur"/>
+        <a:font script="Geor" typeface="Sylfaen"/>
+        <a:font script="Armn" typeface="Arial"/>
+        <a:font script="Bugi" typeface="Leelawadee UI"/>
+        <a:font script="Bopo" typeface="Microsoft JhengHei"/>
+        <a:font script="Java" typeface="Javanese Text"/>
+        <a:font script="Lisu" typeface="Segoe UI"/>
+        <a:font script="Mymr" typeface="Myanmar Text"/>
+        <a:font script="Nkoo" typeface="Ebrima"/>
+        <a:font script="Olck" typeface="Nirmala UI"/>
+        <a:font script="Osma" typeface="Ebrima"/>
+        <a:font script="Phag" typeface="Phagspa"/>
+        <a:font script="Syrn" typeface="Estrangelo Edessa"/>
+        <a:font script="Syrj" typeface="Estrangelo Edessa"/>
+        <a:font script="Syre" typeface="Estrangelo Edessa"/>
+        <a:font script="Sora" typeface="Nirmala UI"/>
+        <a:font script="Tale" typeface="Microsoft Tai Le"/>
+        <a:font script="Talu" typeface="Microsoft New Tai Lue"/>
+        <a:font script="Tfng" typeface="Ebrima"/>
+      </a:minorFont>
+    </a:fontScheme>
+    <a:fmtScheme name="Office">
+      <a:fillStyleLst>
+        <a:solidFill>
+          <a:schemeClr val="phClr"/>
+        </a:solidFill>
+        <a:gradFill rotWithShape="1">
+          <a:gsLst>
+            <a:gs pos="0">
+              <a:schemeClr val="phClr">
+                <a:lumMod val="110000"/>
+                <a:satMod val="105000"/>
+                <a:tint val="67000"/>
+              </a:schemeClr>
+            </a:gs>
+            <a:gs pos="50000">
+              <a:schemeClr val="phClr">
+                <a:lumMod val="105000"/>
+                <a:satMod val="103000"/>
+                <a:tint val="73000"/>
+              </a:schemeClr>
+            </a:gs>
+            <a:gs pos="100000">
+              <a:schemeClr val="phClr">
+                <a:lumMod val="105000"/>
+                <a:satMod val="109000"/>
+                <a:tint val="81000"/>
+              </a:schemeClr>
+            </a:gs>
+          </a:gsLst>
+          <a:lin ang="5400000" scaled="0"/>
+        </a:gradFill>
+        <a:gradFill rotWithShape="1">
+          <a:gsLst>
+            <a:gs pos="0">
+              <a:schemeClr val="phClr">
+                <a:satMod val="103000"/>
+                <a:lumMod val="102000"/>
+                <a:tint val="94000"/>
+              </a:schemeClr>
+            </a:gs>
+            <a:gs pos="50000">
+              <a:schemeClr val="phClr">
+                <a:satMod val="110000"/>
+                <a:lumMod val="100000"/>
+                <a:shade val="100000"/>
+              </a:schemeClr>
+            </a:gs>
+            <a:gs pos="100000">
+              <a:schemeClr val="phClr">
+                <a:lumMod val="99000"/>
+                <a:satMod val="120000"/>
+                <a:shade val="78000"/>
+              </a:schemeClr>
+            </a:gs>
+          </a:gsLst>
+          <a:lin ang="5400000" scaled="0"/>
+        </a:gradFill>
+      </a:fillStyleLst>
+      <a:lnStyleLst>
+        <a:ln w="12700" cap="flat" cmpd="sng" algn="ctr">
+          <a:solidFill>
+            <a:schemeClr val="phClr"/>
+          </a:solidFill>
+          <a:prstDash val="solid"/>
+          <a:miter lim="800000"/>
+        </a:ln>
+        <a:ln w="19050" cap="flat" cmpd="sng" algn="ctr">
+          <a:solidFill>
+            <a:schemeClr val="phClr"/>
+          </a:solidFill>
+          <a:prstDash val="solid"/>
+          <a:miter lim="800000"/>
+        </a:ln>
+        <a:ln w="25400" cap="flat" cmpd="sng" algn="ctr">
+          <a:solidFill>
+            <a:schemeClr val="phClr"/>
+          </a:solidFill>
+          <a:prstDash val="solid"/>
+          <a:miter lim="800000"/>
+        </a:ln>
+      </a:lnStyleLst>
+      <a:effectStyleLst>
+        <a:effectStyle>
+          <a:effectLst/>
+        </a:effectStyle>
+        <a:effectStyle>
+          <a:effectLst/>
+        </a:effectStyle>
+        <a:effectStyle>
+          <a:effectLst>
+            <a:outerShdw blurRad="57150" dist="19050" dir="5400000" algn="ctr" rotWithShape="0">
+              <a:srgbClr val="000000">
+                <a:alpha val="63000"/>
+              </a:srgbClr>
+            </a:outerShdw>
+          </a:effectLst>
+        </a:effectStyle>
+      </a:effectStyleLst>
+      <a:bgFillStyleLst>
+        <a:solidFill>
+          <a:schemeClr val="phClr"/>
+        </a:solidFill>
+        <a:solidFill>
+          <a:schemeClr val="phClr">
+            <a:tint val="95000"/>
+            <a:satMod val="170000"/>
+          </a:schemeClr>
+        </a:solidFill>
+        <a:gradFill rotWithShape="1">
+          <a:gsLst>
+            <a:gs pos="0">
+              <a:schemeClr val="phClr">
+                <a:tint val="93000"/>
+                <a:satMod val="150000"/>
+                <a:shade val="98000"/>
+                <a:lumMod val="102000"/>
+              </a:schemeClr>
+            </a:gs>
+            <a:gs pos="50000">
+              <a:schemeClr val="phClr">
+                <a:tint val="98000"/>
+                <a:satMod val="130000"/>
+                <a:shade val="90000"/>
+                <a:lumMod val="103000"/>
+              </a:schemeClr>
+            </a:gs>
+            <a:gs pos="100000">
+              <a:schemeClr val="phClr">
+                <a:shade val="63000"/>
+                <a:satMod val="120000"/>
+              </a:schemeClr>
+            </a:gs>
+          </a:gsLst>
+          <a:lin ang="5400000" scaled="0"/>
+        </a:gradFill>
+      </a:bgFillStyleLst>
+    </a:fmtScheme>
+  </a:themeElements>
+  <a:objectDefaults>
+    <a:lnDef>
+      <a:spPr/>
+      <a:bodyPr/>
+      <a:lstStyle/>
+      <a:style>
+        <a:lnRef idx="2">
+          <a:schemeClr val="accent1"/>
+        </a:lnRef>
+        <a:fillRef idx="0">
+          <a:schemeClr val="accent1"/>
+        </a:fillRef>
+        <a:effectRef idx="1">
+          <a:schemeClr val="accent1"/>
+        </a:effectRef>
+        <a:fontRef idx="minor">
+          <a:schemeClr val="tx1"/>
+        </a:fontRef>
+      </a:style>
+    </a:lnDef>
+  </a:objectDefaults>
+  <a:extraClrSchemeLst/>
+  <a:extLst>
+    <a:ext uri="{05A4C25C-085E-4340-85A3-A5531E510DB2}">
+      <thm15:themeFamily xmlns:thm15="http://schemas.microsoft.com/office/thememl/2012/main" name="Office Theme" id="{2E142A2C-CD16-42D6-873A-C26D2A0506FA}" vid="{1BDDFF52-6CD6-40A5-AB3C-68EB2F1E4D0A}"/>
+    </a:ext>
+  </a:extLst>
+</a:theme>
 </file>
</xml_diff>